<commit_message>
Slides: roteiro, analogias do cotidiano, quiz relâmpago e frases de impacto em cada capítulo
Co-Authored-By: Claude Sonnet 5.5 <noreply@anthropic.com>
Claude-Session: https://claude.ai/code/session_01WqpZuUc8Cxiqiv68xnjUxi
</commit_message>
<xml_diff>
--- a/redes_neurais/slides/cap01_Introducao.pptx
+++ b/redes_neurais/slides/cap01_Introducao.pptx
@@ -17,9 +17,15 @@
     <p:sldId id="265" r:id="rId11"/>
     <p:sldId id="266" r:id="rId12"/>
     <p:sldId id="267" r:id="rId13"/>
+    <p:sldId id="268" r:id="rId14"/>
+    <p:sldId id="269" r:id="rId15"/>
+    <p:sldId id="270" r:id="rId16"/>
+    <p:sldId id="271" r:id="rId17"/>
+    <p:sldId id="272" r:id="rId18"/>
+    <p:sldId id="273" r:id="rId19"/>
   </p:sldIdLst>
   <p:notesMasterIdLst>
-    <p:notesMasterId r:id="rId14"/>
+    <p:notesMasterId r:id="rId20"/>
   </p:notesMasterIdLst>
   <p:sldSz cx="9144000" cy="5143500"/>
   <p:notesSz cx="5143500" cy="9144000"/>
@@ -601,7 +607,7 @@
           <a:p>
             <a:r>
               <a:rPr lang="en-US" dirty="0"/>
-              <a:t>Estes erros reaparecem em todo o livro. Peça exemplos reais de cada um.</a:t>
+              <a:t>Analogia: ajustar o rádio até a estática diminuir. O erro de treino mede a estática ouvida agora; o que importa é a qualidade em estações novas (dados de teste).</a:t>
             </a:r>
             <a:endParaRPr lang="en-US" dirty="0"/>
           </a:p>
@@ -689,7 +695,7 @@
           <a:p>
             <a:r>
               <a:rPr lang="en-US" dirty="0"/>
-              <a:t>Tempo sugerido: 10 minutos. Resposta esperada: relatar mediana e intervalo, nunca só a melhor execução.</a:t>
+              <a:t>Mostre o código do script exp_primeira_rede.py e o resultado. Peça que os estudantes alterem a semente e comparem.</a:t>
             </a:r>
             <a:endParaRPr lang="en-US" dirty="0"/>
           </a:p>
@@ -777,7 +783,7 @@
           <a:p>
             <a:r>
               <a:rPr lang="en-US" dirty="0"/>
-              <a:t>Feche voltando à pergunta inicial. Próximo capítulo: a matemática e as ferramentas.</a:t>
+              <a:t>Estes erros reaparecem em todo o livro. Peça exemplos reais de cada um.</a:t>
             </a:r>
             <a:endParaRPr lang="en-US" dirty="0"/>
           </a:p>
@@ -801,6 +807,534 @@
             <a:fld id="{F7021451-1387-4CA6-816F-3879F97B5CBC}" type="slidenum">
               <a:rPr lang="en-US"/>
               <a:t>12</a:t>
+            </a:fld>
+            <a:endParaRPr lang="en-US"/>
+          </a:p>
+        </p:txBody>
+      </p:sp>
+    </p:spTree>
+    <p:extLst>
+      <p:ext uri="{BB962C8B-B14F-4D97-AF65-F5344CB8AC3E}">
+        <p14:creationId xmlns:p14="http://schemas.microsoft.com/office/powerpoint/2010/main" val="1024086991"/>
+      </p:ext>
+    </p:extLst>
+  </p:cSld>
+  <p:clrMapOvr>
+    <a:masterClrMapping/>
+  </p:clrMapOvr>
+</p:notes>
+</file>
+
+<file path=ppt/notesSlides/notesSlide13.xml><?xml version="1.0" encoding="utf-8"?>
+<p:notes xmlns:a="http://schemas.openxmlformats.org/drawingml/2006/main" xmlns:r="http://schemas.openxmlformats.org/officeDocument/2006/relationships" xmlns:p="http://schemas.openxmlformats.org/presentationml/2006/main">
+  <p:cSld>
+    <p:spTree>
+      <p:nvGrpSpPr>
+        <p:cNvPr id="1" name=""/>
+        <p:cNvGrpSpPr/>
+        <p:nvPr/>
+      </p:nvGrpSpPr>
+      <p:grpSpPr>
+        <a:xfrm>
+          <a:off x="0" y="0"/>
+          <a:ext cx="0" cy="0"/>
+          <a:chOff x="0" y="0"/>
+          <a:chExt cx="0" cy="0"/>
+        </a:xfrm>
+      </p:grpSpPr>
+      <p:sp>
+        <p:nvSpPr>
+          <p:cNvPr id="2" name="Slide Image Placeholder 1"/>
+          <p:cNvSpPr>
+            <a:spLocks noGrp="1" noRot="1" noChangeAspect="1"/>
+          </p:cNvSpPr>
+          <p:nvPr>
+            <p:ph type="sldImg"/>
+          </p:nvPr>
+        </p:nvSpPr>
+        <p:spPr/>
+      </p:sp>
+      <p:sp>
+        <p:nvSpPr>
+          <p:cNvPr id="3" name="Notes Placeholder 2"/>
+          <p:cNvSpPr>
+            <a:spLocks noGrp="1"/>
+          </p:cNvSpPr>
+          <p:nvPr>
+            <p:ph type="body" idx="1"/>
+          </p:nvPr>
+        </p:nvSpPr>
+        <p:spPr/>
+        <p:txBody>
+          <a:bodyPr/>
+          <a:lstStyle/>
+          <a:p>
+            <a:r>
+              <a:rPr lang="en-US" dirty="0"/>
+              <a:t>Reforce que o erro só existe quando há um alvo para comparar.</a:t>
+            </a:r>
+            <a:endParaRPr lang="en-US" dirty="0"/>
+          </a:p>
+        </p:txBody>
+      </p:sp>
+      <p:sp>
+        <p:nvSpPr>
+          <p:cNvPr id="4" name="Slide Number Placeholder 3"/>
+          <p:cNvSpPr>
+            <a:spLocks noGrp="1"/>
+          </p:cNvSpPr>
+          <p:nvPr>
+            <p:ph type="sldNum" sz="quarter" idx="10"/>
+          </p:nvPr>
+        </p:nvSpPr>
+        <p:spPr/>
+        <p:txBody>
+          <a:bodyPr/>
+          <a:lstStyle/>
+          <a:p>
+            <a:fld id="{F7021451-1387-4CA6-816F-3879F97B5CBC}" type="slidenum">
+              <a:rPr lang="en-US"/>
+              <a:t>13</a:t>
+            </a:fld>
+            <a:endParaRPr lang="en-US"/>
+          </a:p>
+        </p:txBody>
+      </p:sp>
+    </p:spTree>
+    <p:extLst>
+      <p:ext uri="{BB962C8B-B14F-4D97-AF65-F5344CB8AC3E}">
+        <p14:creationId xmlns:p14="http://schemas.microsoft.com/office/powerpoint/2010/main" val="1024086991"/>
+      </p:ext>
+    </p:extLst>
+  </p:cSld>
+  <p:clrMapOvr>
+    <a:masterClrMapping/>
+  </p:clrMapOvr>
+</p:notes>
+</file>
+
+<file path=ppt/notesSlides/notesSlide14.xml><?xml version="1.0" encoding="utf-8"?>
+<p:notes xmlns:a="http://schemas.openxmlformats.org/drawingml/2006/main" xmlns:r="http://schemas.openxmlformats.org/officeDocument/2006/relationships" xmlns:p="http://schemas.openxmlformats.org/presentationml/2006/main">
+  <p:cSld>
+    <p:spTree>
+      <p:nvGrpSpPr>
+        <p:cNvPr id="1" name=""/>
+        <p:cNvGrpSpPr/>
+        <p:nvPr/>
+      </p:nvGrpSpPr>
+      <p:grpSpPr>
+        <a:xfrm>
+          <a:off x="0" y="0"/>
+          <a:ext cx="0" cy="0"/>
+          <a:chOff x="0" y="0"/>
+          <a:chExt cx="0" cy="0"/>
+        </a:xfrm>
+      </p:grpSpPr>
+      <p:sp>
+        <p:nvSpPr>
+          <p:cNvPr id="2" name="Slide Image Placeholder 1"/>
+          <p:cNvSpPr>
+            <a:spLocks noGrp="1" noRot="1" noChangeAspect="1"/>
+          </p:cNvSpPr>
+          <p:nvPr>
+            <p:ph type="sldImg"/>
+          </p:nvPr>
+        </p:nvSpPr>
+        <p:spPr/>
+      </p:sp>
+      <p:sp>
+        <p:nvSpPr>
+          <p:cNvPr id="3" name="Notes Placeholder 2"/>
+          <p:cNvSpPr>
+            <a:spLocks noGrp="1"/>
+          </p:cNvSpPr>
+          <p:nvPr>
+            <p:ph type="body" idx="1"/>
+          </p:nvPr>
+        </p:nvSpPr>
+        <p:spPr/>
+        <p:txBody>
+          <a:bodyPr/>
+          <a:lstStyle/>
+          <a:p>
+            <a:r>
+              <a:rPr lang="en-US" dirty="0"/>
+              <a:t>Resposta: A) Os botões que o treino ajusta. Pesos (e vieses) formam o vetor θ que o treino ajusta. Dê um minuto para votação antes de revelar.</a:t>
+            </a:r>
+            <a:endParaRPr lang="en-US" dirty="0"/>
+          </a:p>
+        </p:txBody>
+      </p:sp>
+      <p:sp>
+        <p:nvSpPr>
+          <p:cNvPr id="4" name="Slide Number Placeholder 3"/>
+          <p:cNvSpPr>
+            <a:spLocks noGrp="1"/>
+          </p:cNvSpPr>
+          <p:nvPr>
+            <p:ph type="sldNum" sz="quarter" idx="10"/>
+          </p:nvPr>
+        </p:nvSpPr>
+        <p:spPr/>
+        <p:txBody>
+          <a:bodyPr/>
+          <a:lstStyle/>
+          <a:p>
+            <a:fld id="{F7021451-1387-4CA6-816F-3879F97B5CBC}" type="slidenum">
+              <a:rPr lang="en-US"/>
+              <a:t>14</a:t>
+            </a:fld>
+            <a:endParaRPr lang="en-US"/>
+          </a:p>
+        </p:txBody>
+      </p:sp>
+    </p:spTree>
+    <p:extLst>
+      <p:ext uri="{BB962C8B-B14F-4D97-AF65-F5344CB8AC3E}">
+        <p14:creationId xmlns:p14="http://schemas.microsoft.com/office/powerpoint/2010/main" val="1024086991"/>
+      </p:ext>
+    </p:extLst>
+  </p:cSld>
+  <p:clrMapOvr>
+    <a:masterClrMapping/>
+  </p:clrMapOvr>
+</p:notes>
+</file>
+
+<file path=ppt/notesSlides/notesSlide15.xml><?xml version="1.0" encoding="utf-8"?>
+<p:notes xmlns:a="http://schemas.openxmlformats.org/drawingml/2006/main" xmlns:r="http://schemas.openxmlformats.org/officeDocument/2006/relationships" xmlns:p="http://schemas.openxmlformats.org/presentationml/2006/main">
+  <p:cSld>
+    <p:spTree>
+      <p:nvGrpSpPr>
+        <p:cNvPr id="1" name=""/>
+        <p:cNvGrpSpPr/>
+        <p:nvPr/>
+      </p:nvGrpSpPr>
+      <p:grpSpPr>
+        <a:xfrm>
+          <a:off x="0" y="0"/>
+          <a:ext cx="0" cy="0"/>
+          <a:chOff x="0" y="0"/>
+          <a:chExt cx="0" cy="0"/>
+        </a:xfrm>
+      </p:grpSpPr>
+      <p:sp>
+        <p:nvSpPr>
+          <p:cNvPr id="2" name="Slide Image Placeholder 1"/>
+          <p:cNvSpPr>
+            <a:spLocks noGrp="1" noRot="1" noChangeAspect="1"/>
+          </p:cNvSpPr>
+          <p:nvPr>
+            <p:ph type="sldImg"/>
+          </p:nvPr>
+        </p:nvSpPr>
+        <p:spPr/>
+      </p:sp>
+      <p:sp>
+        <p:nvSpPr>
+          <p:cNvPr id="3" name="Notes Placeholder 2"/>
+          <p:cNvSpPr>
+            <a:spLocks noGrp="1"/>
+          </p:cNvSpPr>
+          <p:nvPr>
+            <p:ph type="body" idx="1"/>
+          </p:nvPr>
+        </p:nvSpPr>
+        <p:spPr/>
+        <p:txBody>
+          <a:bodyPr/>
+          <a:lstStyle/>
+          <a:p>
+            <a:r>
+              <a:rPr lang="en-US" dirty="0"/>
+              <a:t>Resposta: C) Teste. O teste fica intocado até o relato final; usar o teste para escolher hiperparâmetros é vazamento. Dê um minuto para votação antes de revelar.</a:t>
+            </a:r>
+            <a:endParaRPr lang="en-US" dirty="0"/>
+          </a:p>
+        </p:txBody>
+      </p:sp>
+      <p:sp>
+        <p:nvSpPr>
+          <p:cNvPr id="4" name="Slide Number Placeholder 3"/>
+          <p:cNvSpPr>
+            <a:spLocks noGrp="1"/>
+          </p:cNvSpPr>
+          <p:nvPr>
+            <p:ph type="sldNum" sz="quarter" idx="10"/>
+          </p:nvPr>
+        </p:nvSpPr>
+        <p:spPr/>
+        <p:txBody>
+          <a:bodyPr/>
+          <a:lstStyle/>
+          <a:p>
+            <a:fld id="{F7021451-1387-4CA6-816F-3879F97B5CBC}" type="slidenum">
+              <a:rPr lang="en-US"/>
+              <a:t>15</a:t>
+            </a:fld>
+            <a:endParaRPr lang="en-US"/>
+          </a:p>
+        </p:txBody>
+      </p:sp>
+    </p:spTree>
+    <p:extLst>
+      <p:ext uri="{BB962C8B-B14F-4D97-AF65-F5344CB8AC3E}">
+        <p14:creationId xmlns:p14="http://schemas.microsoft.com/office/powerpoint/2010/main" val="1024086991"/>
+      </p:ext>
+    </p:extLst>
+  </p:cSld>
+  <p:clrMapOvr>
+    <a:masterClrMapping/>
+  </p:clrMapOvr>
+</p:notes>
+</file>
+
+<file path=ppt/notesSlides/notesSlide16.xml><?xml version="1.0" encoding="utf-8"?>
+<p:notes xmlns:a="http://schemas.openxmlformats.org/drawingml/2006/main" xmlns:r="http://schemas.openxmlformats.org/officeDocument/2006/relationships" xmlns:p="http://schemas.openxmlformats.org/presentationml/2006/main">
+  <p:cSld>
+    <p:spTree>
+      <p:nvGrpSpPr>
+        <p:cNvPr id="1" name=""/>
+        <p:cNvGrpSpPr/>
+        <p:nvPr/>
+      </p:nvGrpSpPr>
+      <p:grpSpPr>
+        <a:xfrm>
+          <a:off x="0" y="0"/>
+          <a:ext cx="0" cy="0"/>
+          <a:chOff x="0" y="0"/>
+          <a:chExt cx="0" cy="0"/>
+        </a:xfrm>
+      </p:grpSpPr>
+      <p:sp>
+        <p:nvSpPr>
+          <p:cNvPr id="2" name="Slide Image Placeholder 1"/>
+          <p:cNvSpPr>
+            <a:spLocks noGrp="1" noRot="1" noChangeAspect="1"/>
+          </p:cNvSpPr>
+          <p:nvPr>
+            <p:ph type="sldImg"/>
+          </p:nvPr>
+        </p:nvSpPr>
+        <p:spPr/>
+      </p:sp>
+      <p:sp>
+        <p:nvSpPr>
+          <p:cNvPr id="3" name="Notes Placeholder 2"/>
+          <p:cNvSpPr>
+            <a:spLocks noGrp="1"/>
+          </p:cNvSpPr>
+          <p:nvPr>
+            <p:ph type="body" idx="1"/>
+          </p:nvPr>
+        </p:nvSpPr>
+        <p:spPr/>
+        <p:txBody>
+          <a:bodyPr/>
+          <a:lstStyle/>
+          <a:p>
+            <a:r>
+              <a:rPr lang="en-US" dirty="0"/>
+              <a:t>Tempo sugerido: 10 minutos. Resposta esperada: relatar mediana e intervalo, nunca só a melhor execução.</a:t>
+            </a:r>
+            <a:endParaRPr lang="en-US" dirty="0"/>
+          </a:p>
+        </p:txBody>
+      </p:sp>
+      <p:sp>
+        <p:nvSpPr>
+          <p:cNvPr id="4" name="Slide Number Placeholder 3"/>
+          <p:cNvSpPr>
+            <a:spLocks noGrp="1"/>
+          </p:cNvSpPr>
+          <p:nvPr>
+            <p:ph type="sldNum" sz="quarter" idx="10"/>
+          </p:nvPr>
+        </p:nvSpPr>
+        <p:spPr/>
+        <p:txBody>
+          <a:bodyPr/>
+          <a:lstStyle/>
+          <a:p>
+            <a:fld id="{F7021451-1387-4CA6-816F-3879F97B5CBC}" type="slidenum">
+              <a:rPr lang="en-US"/>
+              <a:t>16</a:t>
+            </a:fld>
+            <a:endParaRPr lang="en-US"/>
+          </a:p>
+        </p:txBody>
+      </p:sp>
+    </p:spTree>
+    <p:extLst>
+      <p:ext uri="{BB962C8B-B14F-4D97-AF65-F5344CB8AC3E}">
+        <p14:creationId xmlns:p14="http://schemas.microsoft.com/office/powerpoint/2010/main" val="1024086991"/>
+      </p:ext>
+    </p:extLst>
+  </p:cSld>
+  <p:clrMapOvr>
+    <a:masterClrMapping/>
+  </p:clrMapOvr>
+</p:notes>
+</file>
+
+<file path=ppt/notesSlides/notesSlide17.xml><?xml version="1.0" encoding="utf-8"?>
+<p:notes xmlns:a="http://schemas.openxmlformats.org/drawingml/2006/main" xmlns:r="http://schemas.openxmlformats.org/officeDocument/2006/relationships" xmlns:p="http://schemas.openxmlformats.org/presentationml/2006/main">
+  <p:cSld>
+    <p:spTree>
+      <p:nvGrpSpPr>
+        <p:cNvPr id="1" name=""/>
+        <p:cNvGrpSpPr/>
+        <p:nvPr/>
+      </p:nvGrpSpPr>
+      <p:grpSpPr>
+        <a:xfrm>
+          <a:off x="0" y="0"/>
+          <a:ext cx="0" cy="0"/>
+          <a:chOff x="0" y="0"/>
+          <a:chExt cx="0" cy="0"/>
+        </a:xfrm>
+      </p:grpSpPr>
+      <p:sp>
+        <p:nvSpPr>
+          <p:cNvPr id="2" name="Slide Image Placeholder 1"/>
+          <p:cNvSpPr>
+            <a:spLocks noGrp="1" noRot="1" noChangeAspect="1"/>
+          </p:cNvSpPr>
+          <p:nvPr>
+            <p:ph type="sldImg"/>
+          </p:nvPr>
+        </p:nvSpPr>
+        <p:spPr/>
+      </p:sp>
+      <p:sp>
+        <p:nvSpPr>
+          <p:cNvPr id="3" name="Notes Placeholder 2"/>
+          <p:cNvSpPr>
+            <a:spLocks noGrp="1"/>
+          </p:cNvSpPr>
+          <p:nvPr>
+            <p:ph type="body" idx="1"/>
+          </p:nvPr>
+        </p:nvSpPr>
+        <p:spPr/>
+        <p:txBody>
+          <a:bodyPr/>
+          <a:lstStyle/>
+          <a:p>
+            <a:r>
+              <a:rPr lang="en-US" dirty="0"/>
+              <a:t>Feche voltando à pergunta inicial. Próximo capítulo: a matemática e as ferramentas.</a:t>
+            </a:r>
+            <a:endParaRPr lang="en-US" dirty="0"/>
+          </a:p>
+        </p:txBody>
+      </p:sp>
+      <p:sp>
+        <p:nvSpPr>
+          <p:cNvPr id="4" name="Slide Number Placeholder 3"/>
+          <p:cNvSpPr>
+            <a:spLocks noGrp="1"/>
+          </p:cNvSpPr>
+          <p:nvPr>
+            <p:ph type="sldNum" sz="quarter" idx="10"/>
+          </p:nvPr>
+        </p:nvSpPr>
+        <p:spPr/>
+        <p:txBody>
+          <a:bodyPr/>
+          <a:lstStyle/>
+          <a:p>
+            <a:fld id="{F7021451-1387-4CA6-816F-3879F97B5CBC}" type="slidenum">
+              <a:rPr lang="en-US"/>
+              <a:t>17</a:t>
+            </a:fld>
+            <a:endParaRPr lang="en-US"/>
+          </a:p>
+        </p:txBody>
+      </p:sp>
+    </p:spTree>
+    <p:extLst>
+      <p:ext uri="{BB962C8B-B14F-4D97-AF65-F5344CB8AC3E}">
+        <p14:creationId xmlns:p14="http://schemas.microsoft.com/office/powerpoint/2010/main" val="1024086991"/>
+      </p:ext>
+    </p:extLst>
+  </p:cSld>
+  <p:clrMapOvr>
+    <a:masterClrMapping/>
+  </p:clrMapOvr>
+</p:notes>
+</file>
+
+<file path=ppt/notesSlides/notesSlide18.xml><?xml version="1.0" encoding="utf-8"?>
+<p:notes xmlns:a="http://schemas.openxmlformats.org/drawingml/2006/main" xmlns:r="http://schemas.openxmlformats.org/officeDocument/2006/relationships" xmlns:p="http://schemas.openxmlformats.org/presentationml/2006/main">
+  <p:cSld>
+    <p:spTree>
+      <p:nvGrpSpPr>
+        <p:cNvPr id="1" name=""/>
+        <p:cNvGrpSpPr/>
+        <p:nvPr/>
+      </p:nvGrpSpPr>
+      <p:grpSpPr>
+        <a:xfrm>
+          <a:off x="0" y="0"/>
+          <a:ext cx="0" cy="0"/>
+          <a:chOff x="0" y="0"/>
+          <a:chExt cx="0" cy="0"/>
+        </a:xfrm>
+      </p:grpSpPr>
+      <p:sp>
+        <p:nvSpPr>
+          <p:cNvPr id="2" name="Slide Image Placeholder 1"/>
+          <p:cNvSpPr>
+            <a:spLocks noGrp="1" noRot="1" noChangeAspect="1"/>
+          </p:cNvSpPr>
+          <p:nvPr>
+            <p:ph type="sldImg"/>
+          </p:nvPr>
+        </p:nvSpPr>
+        <p:spPr/>
+      </p:sp>
+      <p:sp>
+        <p:nvSpPr>
+          <p:cNvPr id="3" name="Notes Placeholder 2"/>
+          <p:cNvSpPr>
+            <a:spLocks noGrp="1"/>
+          </p:cNvSpPr>
+          <p:nvPr>
+            <p:ph type="body" idx="1"/>
+          </p:nvPr>
+        </p:nvSpPr>
+        <p:spPr/>
+        <p:txBody>
+          <a:bodyPr/>
+          <a:lstStyle/>
+          <a:p>
+            <a:r>
+              <a:rPr lang="en-US" dirty="0"/>
+              <a:t>Feche com a frase e peça que os estudantes a expliquem com as próprias palavras.</a:t>
+            </a:r>
+            <a:endParaRPr lang="en-US" dirty="0"/>
+          </a:p>
+        </p:txBody>
+      </p:sp>
+      <p:sp>
+        <p:nvSpPr>
+          <p:cNvPr id="4" name="Slide Number Placeholder 3"/>
+          <p:cNvSpPr>
+            <a:spLocks noGrp="1"/>
+          </p:cNvSpPr>
+          <p:nvPr>
+            <p:ph type="sldNum" sz="quarter" idx="10"/>
+          </p:nvPr>
+        </p:nvSpPr>
+        <p:spPr/>
+        <p:txBody>
+          <a:bodyPr/>
+          <a:lstStyle/>
+          <a:p>
+            <a:fld id="{F7021451-1387-4CA6-816F-3879F97B5CBC}" type="slidenum">
+              <a:rPr lang="en-US"/>
+              <a:t>18</a:t>
             </a:fld>
             <a:endParaRPr lang="en-US"/>
           </a:p>
@@ -865,7 +1399,7 @@
           <a:p>
             <a:r>
               <a:rPr lang="en-US" dirty="0"/>
-              <a:t>Abra com a pergunta: como um programa aprende a reconhecer um padrão sem que ninguém escreva a regra? Diga que o fio condutor do livro é um só: ajustar pesos para diminuir um erro.</a:t>
+              <a:t>Apresente o roteiro e o tempo estimado de cada bloco (cerca de 2 minutos por slide).</a:t>
             </a:r>
             <a:endParaRPr lang="en-US" dirty="0"/>
           </a:p>
@@ -953,7 +1487,7 @@
           <a:p>
             <a:r>
               <a:rPr lang="en-US" dirty="0"/>
-              <a:t>Leia os objetivos em voz alta e peça que os estudantes marquem qual deles consideram mais difícil.</a:t>
+              <a:t>Abra com a pergunta: como um programa aprende a reconhecer um padrão sem que ninguém escreva a regra? Diga que o fio condutor do livro é um só: ajustar pesos para diminuir um erro.</a:t>
             </a:r>
             <a:endParaRPr lang="en-US" dirty="0"/>
           </a:p>
@@ -1041,7 +1575,7 @@
           <a:p>
             <a:r>
               <a:rPr lang="en-US" dirty="0"/>
-              <a:t>Percorra a linha do tempo sem entrar em detalhes. Cada marco volta nos capítulos seguintes. Cuidado: evite afirmar quem 'inventou' o backpropagation; a história tem vários autores.</a:t>
+              <a:t>Leia os objetivos em voz alta e peça que os estudantes marquem qual deles consideram mais difícil.</a:t>
             </a:r>
             <a:endParaRPr lang="en-US" dirty="0"/>
           </a:p>
@@ -1129,7 +1663,7 @@
           <a:p>
             <a:r>
               <a:rPr lang="en-US" dirty="0"/>
-              <a:t>Analogia: o neurônio é um júri que pesa as opiniões (entradas) por sua confiança (pesos) e decide pela ativação.</a:t>
+              <a:t>Analogia do livro. Peça que os estudantes completem: o que seria o 'ruído' nessa mesa? (dados com erro).</a:t>
             </a:r>
             <a:endParaRPr lang="en-US" dirty="0"/>
           </a:p>
@@ -1217,7 +1751,7 @@
           <a:p>
             <a:r>
               <a:rPr lang="en-US" dirty="0"/>
-              <a:t>Faça o cálculo com números pequenos no quadro: w = (2, -1), x = (1, 3), b = 0,5 dá z = -0,5.</a:t>
+              <a:t>Percorra a linha do tempo sem entrar em detalhes. Cada marco volta nos capítulos seguintes. Cuidado: evite afirmar quem 'inventou' o backpropagation; a história tem vários autores.</a:t>
             </a:r>
             <a:endParaRPr lang="en-US" dirty="0"/>
           </a:p>
@@ -1305,7 +1839,7 @@
           <a:p>
             <a:r>
               <a:rPr lang="en-US" dirty="0"/>
-              <a:t>Insista na convenção do livro: amostras nas linhas, W de dimensão n_l × n_{l-1}. Conferir dimensões evita metade dos erros.</a:t>
+              <a:t>Analogia: o neurônio é um júri que pesa as opiniões (entradas) por sua confiança (pesos) e decide pela ativação.</a:t>
             </a:r>
             <a:endParaRPr lang="en-US" dirty="0"/>
           </a:p>
@@ -1393,7 +1927,7 @@
           <a:p>
             <a:r>
               <a:rPr lang="en-US" dirty="0"/>
-              <a:t>Analogia: ajustar o rádio até a estática diminuir. O erro de treino mede a estática ouvida agora; o que importa é a qualidade em estações novas (dados de teste).</a:t>
+              <a:t>Faça o cálculo com números pequenos no quadro: w = (2, -1), x = (1, 3), b = 0,5 dá z = -0,5.</a:t>
             </a:r>
             <a:endParaRPr lang="en-US" dirty="0"/>
           </a:p>
@@ -1481,7 +2015,7 @@
           <a:p>
             <a:r>
               <a:rPr lang="en-US" dirty="0"/>
-              <a:t>Mostre o código do script exp_primeira_rede.py e o resultado. Peça que os estudantes alterem a semente e comparem.</a:t>
+              <a:t>Insista na convenção do livro: amostras nas linhas, W de dimensão n_l × n_{l-1}. Conferir dimensões evita metade dos erros.</a:t>
             </a:r>
             <a:endParaRPr lang="en-US" dirty="0"/>
           </a:p>
@@ -2290,7 +2824,7 @@
                 <a:ea typeface="Calibri" pitchFamily="34" charset="-122"/>
                 <a:cs typeface="Calibri" pitchFamily="34" charset="-120"/>
               </a:rPr>
-              <a:t>Erros frequentes</a:t>
+              <a:t>Aprender é diminuir um erro</a:t>
             </a:r>
             <a:endParaRPr lang="en-US" sz="2600" dirty="0"/>
           </a:p>
@@ -2332,7 +2866,7 @@
                   <a:srgbClr val="1F2937"/>
                 </a:solidFill>
               </a:rPr>
-              <a:t>Confundir erro de treino com desempenho em dados novos</a:t>
+              <a:t>Resíduo: r = y − t (saída menos alvo)</a:t>
             </a:r>
             <a:endParaRPr lang="en-US" sz="2400" dirty="0"/>
           </a:p>
@@ -2350,7 +2884,7 @@
                   <a:srgbClr val="1F2937"/>
                 </a:solidFill>
               </a:rPr>
-              <a:t>Escalar os dados usando também validação e teste (vazamento)</a:t>
+              <a:t>Erro: E = ½ Σ r²</a:t>
             </a:r>
             <a:endParaRPr lang="en-US" sz="2400" dirty="0"/>
           </a:p>
@@ -2368,7 +2902,7 @@
                   <a:srgbClr val="1F2937"/>
                 </a:solidFill>
               </a:rPr>
-              <a:t>Achar que mais neurônios é sempre melhor</a:t>
+              <a:t>Treinar = escolher θ que torna E pequeno</a:t>
             </a:r>
             <a:endParaRPr lang="en-US" sz="2400" dirty="0"/>
           </a:p>
@@ -2386,7 +2920,7 @@
                   <a:srgbClr val="1F2937"/>
                 </a:solidFill>
               </a:rPr>
-              <a:t>Concluir tudo a partir de uma única semente</a:t>
+              <a:t>Mas o objetivo real é acertar em dados novos</a:t>
             </a:r>
             <a:endParaRPr lang="en-US" sz="2400" dirty="0"/>
           </a:p>
@@ -2497,85 +3031,46 @@
                 <a:ea typeface="Calibri" pitchFamily="34" charset="-122"/>
                 <a:cs typeface="Calibri" pitchFamily="34" charset="-120"/>
               </a:rPr>
-              <a:t>Atividade</a:t>
+              <a:t>A primeira rede</a:t>
             </a:r>
             <a:endParaRPr lang="en-US" sz="2600" dirty="0"/>
           </a:p>
         </p:txBody>
       </p:sp>
-      <p:sp>
-        <p:nvSpPr>
-          <p:cNvPr id="3" name="Shape 1"/>
-          <p:cNvSpPr/>
-          <p:nvPr/>
-        </p:nvSpPr>
-        <p:spPr>
-          <a:xfrm>
-            <a:off x="548640" y="1188720"/>
-            <a:ext cx="8046720" cy="3108960"/>
-          </a:xfrm>
-          <a:prstGeom prst="roundRect">
-            <a:avLst>
-              <a:gd name="adj" fmla="val 3529"/>
-            </a:avLst>
-          </a:prstGeom>
-          <a:solidFill>
-            <a:srgbClr val="FFFBEB"/>
-          </a:solidFill>
-          <a:ln w="25400">
-            <a:solidFill>
-              <a:srgbClr val="F59E0B"/>
-            </a:solidFill>
-            <a:prstDash val="solid"/>
-          </a:ln>
-        </p:spPr>
-      </p:sp>
-      <p:sp>
-        <p:nvSpPr>
-          <p:cNvPr id="4" name="Text 2"/>
+      <p:pic>
+        <p:nvPicPr>
+          <p:cNvPr id="3" name="Image 0" descr="Rede treinada com a infraestrutura didática do livro.">    </p:cNvPr>
+          <p:cNvPicPr>
+            <a:picLocks noChangeAspect="1"/>
+          </p:cNvPicPr>
+          <p:nvPr/>
+        </p:nvPicPr>
+        <p:blipFill>
+          <a:blip r:embed="rId1"/>
+          <a:stretch>
+            <a:fillRect/>
+          </a:stretch>
+        </p:blipFill>
+        <p:spPr>
+          <a:xfrm>
+            <a:off x="910776" y="1005840"/>
+            <a:ext cx="7322448" cy="3154680"/>
+          </a:xfrm>
+          <a:prstGeom prst="rect">
+            <a:avLst/>
+          </a:prstGeom>
+        </p:spPr>
+      </p:pic>
+      <p:sp>
+        <p:nvSpPr>
+          <p:cNvPr id="4" name="Text 1"/>
           <p:cNvSpPr txBox="1"/>
           <p:nvPr/>
         </p:nvSpPr>
         <p:spPr>
           <a:xfrm>
-            <a:off x="822960" y="1325880"/>
-            <a:ext cx="3657600" cy="365760"/>
-          </a:xfrm>
-          <a:prstGeom prst="rect">
-            <a:avLst/>
-          </a:prstGeom>
-          <a:noFill/>
-          <a:ln/>
-        </p:spPr>
-        <p:txBody>
-          <a:bodyPr wrap="square" lIns="0" tIns="0" rIns="0" bIns="0" rtlCol="0" anchor="ctr"/>
-          <a:lstStyle/>
-          <a:p>
-            <a:pPr indent="0" marL="0">
-              <a:buNone/>
-            </a:pPr>
-            <a:r>
-              <a:rPr lang="en-US" sz="1400" b="1" spc="300" kern="0" dirty="0">
-                <a:solidFill>
-                  <a:srgbClr val="B45309"/>
-                </a:solidFill>
-              </a:rPr>
-              <a:t>MÃO NA MASSA</a:t>
-            </a:r>
-            <a:endParaRPr lang="en-US" sz="1400" dirty="0"/>
-          </a:p>
-        </p:txBody>
-      </p:sp>
-      <p:sp>
-        <p:nvSpPr>
-          <p:cNvPr id="5" name="Text 3"/>
-          <p:cNvSpPr txBox="1"/>
-          <p:nvPr/>
-        </p:nvSpPr>
-        <p:spPr>
-          <a:xfrm>
-            <a:off x="822960" y="1783080"/>
-            <a:ext cx="7498080" cy="2377440"/>
+            <a:off x="457200" y="4251960"/>
+            <a:ext cx="8229600" cy="457200"/>
           </a:xfrm>
           <a:prstGeom prst="rect">
             <a:avLst/>
@@ -2589,18 +3084,18 @@
           </a:bodyPr>
           <a:lstStyle/>
           <a:p>
-            <a:pPr indent="0" marL="0">
+            <a:pPr algn="ctr" indent="0" marL="0">
               <a:buNone/>
             </a:pPr>
             <a:r>
-              <a:rPr lang="en-US" sz="2100" dirty="0">
-                <a:solidFill>
-                  <a:srgbClr val="1F2937"/>
-                </a:solidFill>
-              </a:rPr>
-              <a:t>Treine uma rede 1–8–1 em dados sintéticos com três sementes diferentes. Anote o erro final de cada uma. O que a variação entre sementes sugere sobre como relatar resultados?</a:t>
-            </a:r>
-            <a:endParaRPr lang="en-US" sz="2100" dirty="0"/>
+              <a:rPr lang="en-US" sz="1400" i="1" dirty="0">
+                <a:solidFill>
+                  <a:srgbClr val="4B5563"/>
+                </a:solidFill>
+              </a:rPr>
+              <a:t>Rede treinada com a infraestrutura didática do livro.</a:t>
+            </a:r>
+            <a:endParaRPr lang="en-US" sz="1400" dirty="0"/>
           </a:p>
         </p:txBody>
       </p:sp>
@@ -2682,6 +3177,1450 @@
         </p:nvSpPr>
         <p:spPr>
           <a:xfrm>
+            <a:off x="365760" y="109728"/>
+            <a:ext cx="8412480" cy="658368"/>
+          </a:xfrm>
+          <a:prstGeom prst="rect">
+            <a:avLst/>
+          </a:prstGeom>
+          <a:noFill/>
+          <a:ln/>
+        </p:spPr>
+        <p:txBody>
+          <a:bodyPr wrap="square" lIns="0" tIns="0" rIns="0" bIns="0" rtlCol="0" anchor="ctr">
+            <a:normAutofit/>
+          </a:bodyPr>
+          <a:lstStyle/>
+          <a:p>
+            <a:pPr indent="0" marL="0">
+              <a:buNone/>
+            </a:pPr>
+            <a:r>
+              <a:rPr lang="en-US" sz="2600" b="1" dirty="0">
+                <a:solidFill>
+                  <a:srgbClr val="FFFFFF"/>
+                </a:solidFill>
+                <a:latin typeface="Calibri" pitchFamily="34" charset="0"/>
+                <a:ea typeface="Calibri" pitchFamily="34" charset="-122"/>
+                <a:cs typeface="Calibri" pitchFamily="34" charset="-120"/>
+              </a:rPr>
+              <a:t>Erros frequentes</a:t>
+            </a:r>
+            <a:endParaRPr lang="en-US" sz="2600" dirty="0"/>
+          </a:p>
+        </p:txBody>
+      </p:sp>
+      <p:sp>
+        <p:nvSpPr>
+          <p:cNvPr id="3" name="Text 1"/>
+          <p:cNvSpPr txBox="1"/>
+          <p:nvPr/>
+        </p:nvSpPr>
+        <p:spPr>
+          <a:xfrm>
+            <a:off x="548640" y="1188720"/>
+            <a:ext cx="8046720" cy="3383280"/>
+          </a:xfrm>
+          <a:prstGeom prst="rect">
+            <a:avLst/>
+          </a:prstGeom>
+          <a:noFill/>
+          <a:ln/>
+        </p:spPr>
+        <p:txBody>
+          <a:bodyPr wrap="square" lIns="0" tIns="0" rIns="0" bIns="0" rtlCol="0" anchor="t">
+            <a:normAutofit/>
+          </a:bodyPr>
+          <a:lstStyle/>
+          <a:p>
+            <a:pPr marL="342900" indent="-342900">
+              <a:spcAft>
+                <a:spcPts val="1400"/>
+              </a:spcAft>
+              <a:buSzPct val="100000"/>
+              <a:buChar char="•"/>
+            </a:pPr>
+            <a:r>
+              <a:rPr lang="en-US" sz="2400" dirty="0">
+                <a:solidFill>
+                  <a:srgbClr val="1F2937"/>
+                </a:solidFill>
+              </a:rPr>
+              <a:t>Confundir erro de treino com desempenho em dados novos</a:t>
+            </a:r>
+            <a:endParaRPr lang="en-US" sz="2400" dirty="0"/>
+          </a:p>
+          <a:p>
+            <a:pPr marL="342900" indent="-342900">
+              <a:spcAft>
+                <a:spcPts val="1400"/>
+              </a:spcAft>
+              <a:buSzPct val="100000"/>
+              <a:buChar char="•"/>
+            </a:pPr>
+            <a:r>
+              <a:rPr lang="en-US" sz="2400" dirty="0">
+                <a:solidFill>
+                  <a:srgbClr val="1F2937"/>
+                </a:solidFill>
+              </a:rPr>
+              <a:t>Escalar os dados usando também validação e teste (vazamento)</a:t>
+            </a:r>
+            <a:endParaRPr lang="en-US" sz="2400" dirty="0"/>
+          </a:p>
+          <a:p>
+            <a:pPr marL="342900" indent="-342900">
+              <a:spcAft>
+                <a:spcPts val="1400"/>
+              </a:spcAft>
+              <a:buSzPct val="100000"/>
+              <a:buChar char="•"/>
+            </a:pPr>
+            <a:r>
+              <a:rPr lang="en-US" sz="2400" dirty="0">
+                <a:solidFill>
+                  <a:srgbClr val="1F2937"/>
+                </a:solidFill>
+              </a:rPr>
+              <a:t>Achar que mais neurônios é sempre melhor</a:t>
+            </a:r>
+            <a:endParaRPr lang="en-US" sz="2400" dirty="0"/>
+          </a:p>
+          <a:p>
+            <a:pPr marL="342900" indent="-342900">
+              <a:spcAft>
+                <a:spcPts val="1400"/>
+              </a:spcAft>
+              <a:buSzPct val="100000"/>
+              <a:buChar char="•"/>
+            </a:pPr>
+            <a:r>
+              <a:rPr lang="en-US" sz="2400" dirty="0">
+                <a:solidFill>
+                  <a:srgbClr val="1F2937"/>
+                </a:solidFill>
+              </a:rPr>
+              <a:t>Concluir tudo a partir de uma única semente</a:t>
+            </a:r>
+            <a:endParaRPr lang="en-US" sz="2400" dirty="0"/>
+          </a:p>
+        </p:txBody>
+      </p:sp>
+      <p:sp>
+        <p:nvSpPr>
+          <p:cNvPr id="25" name="Slide Number Placeholder 0"/>
+          <p:cNvSpPr>
+            <a:spLocks noGrp="1"/>
+          </p:cNvSpPr>
+          <p:nvPr>
+            <p:ph type="sldNum" sz="quarter" idx="4294967295"/>
+          </p:nvPr>
+        </p:nvSpPr>
+        <p:spPr>
+          <a:xfrm>
+            <a:off x="8412480" y="4828032"/>
+            <a:ext cx="457200" cy="228600"/>
+          </a:xfrm>
+          <a:prstGeom prst="rect">
+            <a:avLst/>
+          </a:prstGeom>
+          <a:extLst>
+            <a:ext uri="{C572A759-6A51-4108-AA02-DFA0A04FC94B}">
+              <ma14:wrappingTextBoxFlag xmlns:ma14="http://schemas.microsoft.com/office/mac/drawingml/2011/main" val="0"/>
+            </a:ext>
+          </a:extLst>
+        </p:spPr>
+        <p:txBody>
+          <a:bodyPr/>
+          <a:lstStyle>
+            <a:lvl1pPr>
+              <a:defRPr sz="900">
+                <a:solidFill>
+                  <a:srgbClr val="6B7280"/>
+                </a:solidFill>
+              </a:defRPr>
+            </a:lvl1pPr>
+          </a:lstStyle>
+          <a:p>
+            <a:pPr algn="l"/>
+            <a:fld id="{F7021451-1387-4CA6-816F-3879F97B5CBC}" type="slidenum">
+              <a:rPr b="0" lang="en-US"/>
+              <a:t>12</a:t>
+            </a:fld>
+            <a:endParaRPr lang="en-US"/>
+          </a:p>
+        </p:txBody>
+      </p:sp>
+    </p:spTree>
+  </p:cSld>
+  <p:clrMapOvr>
+    <a:masterClrMapping/>
+  </p:clrMapOvr>
+</p:sld>
+</file>
+
+<file path=ppt/slides/slide13.xml><?xml version="1.0" encoding="utf-8"?>
+<p:sld xmlns:a="http://schemas.openxmlformats.org/drawingml/2006/main" xmlns:r="http://schemas.openxmlformats.org/officeDocument/2006/relationships" xmlns:p="http://schemas.openxmlformats.org/presentationml/2006/main">
+  <p:cSld name="Slide 13">
+    <p:spTree>
+      <p:nvGrpSpPr>
+        <p:cNvPr id="1" name=""/>
+        <p:cNvGrpSpPr/>
+        <p:nvPr/>
+      </p:nvGrpSpPr>
+      <p:grpSpPr>
+        <a:xfrm>
+          <a:off x="0" y="0"/>
+          <a:ext cx="0" cy="0"/>
+          <a:chOff x="0" y="0"/>
+          <a:chExt cx="0" cy="0"/>
+        </a:xfrm>
+      </p:grpSpPr>
+      <p:sp>
+        <p:nvSpPr>
+          <p:cNvPr id="2" name="Text 0"/>
+          <p:cNvSpPr txBox="1"/>
+          <p:nvPr/>
+        </p:nvSpPr>
+        <p:spPr>
+          <a:xfrm>
+            <a:off x="365760" y="109728"/>
+            <a:ext cx="8412480" cy="658368"/>
+          </a:xfrm>
+          <a:prstGeom prst="rect">
+            <a:avLst/>
+          </a:prstGeom>
+          <a:noFill/>
+          <a:ln/>
+        </p:spPr>
+        <p:txBody>
+          <a:bodyPr wrap="square" lIns="0" tIns="0" rIns="0" bIns="0" rtlCol="0" anchor="ctr">
+            <a:normAutofit/>
+          </a:bodyPr>
+          <a:lstStyle/>
+          <a:p>
+            <a:pPr indent="0" marL="0">
+              <a:buNone/>
+            </a:pPr>
+            <a:r>
+              <a:rPr lang="en-US" sz="2600" b="1" dirty="0">
+                <a:solidFill>
+                  <a:srgbClr val="FFFFFF"/>
+                </a:solidFill>
+                <a:latin typeface="Calibri" pitchFamily="34" charset="0"/>
+                <a:ea typeface="Calibri" pitchFamily="34" charset="-122"/>
+                <a:cs typeface="Calibri" pitchFamily="34" charset="-120"/>
+              </a:rPr>
+              <a:t>Supervisionado × não supervisionado</a:t>
+            </a:r>
+            <a:endParaRPr lang="en-US" sz="2600" dirty="0"/>
+          </a:p>
+        </p:txBody>
+      </p:sp>
+      <p:sp>
+        <p:nvSpPr>
+          <p:cNvPr id="3" name="Text 1"/>
+          <p:cNvSpPr txBox="1"/>
+          <p:nvPr/>
+        </p:nvSpPr>
+        <p:spPr>
+          <a:xfrm>
+            <a:off x="548640" y="1188720"/>
+            <a:ext cx="8046720" cy="3383280"/>
+          </a:xfrm>
+          <a:prstGeom prst="rect">
+            <a:avLst/>
+          </a:prstGeom>
+          <a:noFill/>
+          <a:ln/>
+        </p:spPr>
+        <p:txBody>
+          <a:bodyPr wrap="square" lIns="0" tIns="0" rIns="0" bIns="0" rtlCol="0" anchor="t">
+            <a:normAutofit/>
+          </a:bodyPr>
+          <a:lstStyle/>
+          <a:p>
+            <a:pPr marL="342900" indent="-342900">
+              <a:spcAft>
+                <a:spcPts val="1400"/>
+              </a:spcAft>
+              <a:buSzPct val="100000"/>
+              <a:buChar char="•"/>
+            </a:pPr>
+            <a:r>
+              <a:rPr lang="en-US" sz="2400" dirty="0">
+                <a:solidFill>
+                  <a:srgbClr val="1F2937"/>
+                </a:solidFill>
+              </a:rPr>
+              <a:t>Supervisionado: cada exemplo vem com a resposta (alvo)</a:t>
+            </a:r>
+            <a:endParaRPr lang="en-US" sz="2400" dirty="0"/>
+          </a:p>
+          <a:p>
+            <a:pPr marL="342900" indent="-342900">
+              <a:spcAft>
+                <a:spcPts val="1400"/>
+              </a:spcAft>
+              <a:buSzPct val="100000"/>
+              <a:buChar char="•"/>
+            </a:pPr>
+            <a:r>
+              <a:rPr lang="en-US" sz="2400" dirty="0">
+                <a:solidFill>
+                  <a:srgbClr val="1F2937"/>
+                </a:solidFill>
+              </a:rPr>
+              <a:t>Não supervisionado: só os dados, sem resposta</a:t>
+            </a:r>
+            <a:endParaRPr lang="en-US" sz="2400" dirty="0"/>
+          </a:p>
+          <a:p>
+            <a:pPr marL="342900" indent="-342900">
+              <a:spcAft>
+                <a:spcPts val="1400"/>
+              </a:spcAft>
+              <a:buSzPct val="100000"/>
+              <a:buChar char="•"/>
+            </a:pPr>
+            <a:r>
+              <a:rPr lang="en-US" sz="2400" dirty="0">
+                <a:solidFill>
+                  <a:srgbClr val="1F2937"/>
+                </a:solidFill>
+              </a:rPr>
+              <a:t>Este livro: supervisionado (regressão e classificação)</a:t>
+            </a:r>
+            <a:endParaRPr lang="en-US" sz="2400" dirty="0"/>
+          </a:p>
+          <a:p>
+            <a:pPr marL="342900" indent="-342900">
+              <a:spcAft>
+                <a:spcPts val="1400"/>
+              </a:spcAft>
+              <a:buSzPct val="100000"/>
+              <a:buChar char="•"/>
+            </a:pPr>
+            <a:r>
+              <a:rPr lang="en-US" sz="2400" dirty="0">
+                <a:solidFill>
+                  <a:srgbClr val="1F2937"/>
+                </a:solidFill>
+              </a:rPr>
+              <a:t>Em ambos: separar treino, validação e teste</a:t>
+            </a:r>
+            <a:endParaRPr lang="en-US" sz="2400" dirty="0"/>
+          </a:p>
+        </p:txBody>
+      </p:sp>
+      <p:sp>
+        <p:nvSpPr>
+          <p:cNvPr id="25" name="Slide Number Placeholder 0"/>
+          <p:cNvSpPr>
+            <a:spLocks noGrp="1"/>
+          </p:cNvSpPr>
+          <p:nvPr>
+            <p:ph type="sldNum" sz="quarter" idx="4294967295"/>
+          </p:nvPr>
+        </p:nvSpPr>
+        <p:spPr>
+          <a:xfrm>
+            <a:off x="8412480" y="4828032"/>
+            <a:ext cx="457200" cy="228600"/>
+          </a:xfrm>
+          <a:prstGeom prst="rect">
+            <a:avLst/>
+          </a:prstGeom>
+          <a:extLst>
+            <a:ext uri="{C572A759-6A51-4108-AA02-DFA0A04FC94B}">
+              <ma14:wrappingTextBoxFlag xmlns:ma14="http://schemas.microsoft.com/office/mac/drawingml/2011/main" val="0"/>
+            </a:ext>
+          </a:extLst>
+        </p:spPr>
+        <p:txBody>
+          <a:bodyPr/>
+          <a:lstStyle>
+            <a:lvl1pPr>
+              <a:defRPr sz="900">
+                <a:solidFill>
+                  <a:srgbClr val="6B7280"/>
+                </a:solidFill>
+              </a:defRPr>
+            </a:lvl1pPr>
+          </a:lstStyle>
+          <a:p>
+            <a:pPr algn="l"/>
+            <a:fld id="{F7021451-1387-4CA6-816F-3879F97B5CBC}" type="slidenum">
+              <a:rPr b="0" lang="en-US"/>
+              <a:t>13</a:t>
+            </a:fld>
+            <a:endParaRPr lang="en-US"/>
+          </a:p>
+        </p:txBody>
+      </p:sp>
+    </p:spTree>
+  </p:cSld>
+  <p:clrMapOvr>
+    <a:masterClrMapping/>
+  </p:clrMapOvr>
+</p:sld>
+</file>
+
+<file path=ppt/slides/slide14.xml><?xml version="1.0" encoding="utf-8"?>
+<p:sld xmlns:a="http://schemas.openxmlformats.org/drawingml/2006/main" xmlns:r="http://schemas.openxmlformats.org/officeDocument/2006/relationships" xmlns:p="http://schemas.openxmlformats.org/presentationml/2006/main">
+  <p:cSld name="Slide 14">
+    <p:spTree>
+      <p:nvGrpSpPr>
+        <p:cNvPr id="1" name=""/>
+        <p:cNvGrpSpPr/>
+        <p:nvPr/>
+      </p:nvGrpSpPr>
+      <p:grpSpPr>
+        <a:xfrm>
+          <a:off x="0" y="0"/>
+          <a:ext cx="0" cy="0"/>
+          <a:chOff x="0" y="0"/>
+          <a:chExt cx="0" cy="0"/>
+        </a:xfrm>
+      </p:grpSpPr>
+      <p:sp>
+        <p:nvSpPr>
+          <p:cNvPr id="2" name="Text 0"/>
+          <p:cNvSpPr txBox="1"/>
+          <p:nvPr/>
+        </p:nvSpPr>
+        <p:spPr>
+          <a:xfrm>
+            <a:off x="365760" y="109728"/>
+            <a:ext cx="8412480" cy="658368"/>
+          </a:xfrm>
+          <a:prstGeom prst="rect">
+            <a:avLst/>
+          </a:prstGeom>
+          <a:noFill/>
+          <a:ln/>
+        </p:spPr>
+        <p:txBody>
+          <a:bodyPr wrap="square" lIns="0" tIns="0" rIns="0" bIns="0" rtlCol="0" anchor="ctr">
+            <a:normAutofit/>
+          </a:bodyPr>
+          <a:lstStyle/>
+          <a:p>
+            <a:pPr indent="0" marL="0">
+              <a:buNone/>
+            </a:pPr>
+            <a:r>
+              <a:rPr lang="en-US" sz="2600" b="1" dirty="0">
+                <a:solidFill>
+                  <a:srgbClr val="FFFFFF"/>
+                </a:solidFill>
+                <a:latin typeface="Calibri" pitchFamily="34" charset="0"/>
+                <a:ea typeface="Calibri" pitchFamily="34" charset="-122"/>
+                <a:cs typeface="Calibri" pitchFamily="34" charset="-120"/>
+              </a:rPr>
+              <a:t>Quiz relâmpago 1</a:t>
+            </a:r>
+            <a:endParaRPr lang="en-US" sz="2600" dirty="0"/>
+          </a:p>
+        </p:txBody>
+      </p:sp>
+      <p:sp>
+        <p:nvSpPr>
+          <p:cNvPr id="3" name="Text 1"/>
+          <p:cNvSpPr txBox="1"/>
+          <p:nvPr/>
+        </p:nvSpPr>
+        <p:spPr>
+          <a:xfrm>
+            <a:off x="548640" y="1051560"/>
+            <a:ext cx="8046720" cy="822960"/>
+          </a:xfrm>
+          <a:prstGeom prst="rect">
+            <a:avLst/>
+          </a:prstGeom>
+          <a:noFill/>
+          <a:ln/>
+        </p:spPr>
+        <p:txBody>
+          <a:bodyPr wrap="square" lIns="0" tIns="0" rIns="0" bIns="0" rtlCol="0" anchor="ctr">
+            <a:normAutofit/>
+          </a:bodyPr>
+          <a:lstStyle/>
+          <a:p>
+            <a:pPr indent="0" marL="0">
+              <a:buNone/>
+            </a:pPr>
+            <a:r>
+              <a:rPr lang="en-US" sz="2200" b="1" dirty="0">
+                <a:solidFill>
+                  <a:srgbClr val="312E81"/>
+                </a:solidFill>
+              </a:rPr>
+              <a:t>O que os pesos de uma rede representam?</a:t>
+            </a:r>
+            <a:endParaRPr lang="en-US" sz="2200" dirty="0"/>
+          </a:p>
+        </p:txBody>
+      </p:sp>
+      <p:sp>
+        <p:nvSpPr>
+          <p:cNvPr id="4" name="Shape 2"/>
+          <p:cNvSpPr/>
+          <p:nvPr/>
+        </p:nvSpPr>
+        <p:spPr>
+          <a:xfrm>
+            <a:off x="548640" y="1965960"/>
+            <a:ext cx="8046720" cy="548640"/>
+          </a:xfrm>
+          <a:prstGeom prst="roundRect">
+            <a:avLst>
+              <a:gd name="adj" fmla="val 13333"/>
+            </a:avLst>
+          </a:prstGeom>
+          <a:solidFill>
+            <a:srgbClr val="EEF2FF"/>
+          </a:solidFill>
+          <a:ln w="12700">
+            <a:solidFill>
+              <a:srgbClr val="C7D2FE"/>
+            </a:solidFill>
+            <a:prstDash val="solid"/>
+          </a:ln>
+        </p:spPr>
+      </p:sp>
+      <p:sp>
+        <p:nvSpPr>
+          <p:cNvPr id="5" name="Text 3"/>
+          <p:cNvSpPr txBox="1"/>
+          <p:nvPr/>
+        </p:nvSpPr>
+        <p:spPr>
+          <a:xfrm>
+            <a:off x="777240" y="1965960"/>
+            <a:ext cx="7680960" cy="548640"/>
+          </a:xfrm>
+          <a:prstGeom prst="rect">
+            <a:avLst/>
+          </a:prstGeom>
+          <a:noFill/>
+          <a:ln/>
+        </p:spPr>
+        <p:txBody>
+          <a:bodyPr wrap="square" lIns="0" tIns="0" rIns="0" bIns="0" rtlCol="0" anchor="ctr">
+            <a:normAutofit/>
+          </a:bodyPr>
+          <a:lstStyle/>
+          <a:p>
+            <a:pPr indent="0" marL="0">
+              <a:buNone/>
+            </a:pPr>
+            <a:r>
+              <a:rPr lang="en-US" sz="1800" dirty="0">
+                <a:solidFill>
+                  <a:srgbClr val="1F2937"/>
+                </a:solidFill>
+              </a:rPr>
+              <a:t>A)  Os botões que o treino ajusta</a:t>
+            </a:r>
+            <a:endParaRPr lang="en-US" sz="1800" dirty="0"/>
+          </a:p>
+        </p:txBody>
+      </p:sp>
+      <p:sp>
+        <p:nvSpPr>
+          <p:cNvPr id="6" name="Shape 4"/>
+          <p:cNvSpPr/>
+          <p:nvPr/>
+        </p:nvSpPr>
+        <p:spPr>
+          <a:xfrm>
+            <a:off x="548640" y="2606040"/>
+            <a:ext cx="8046720" cy="548640"/>
+          </a:xfrm>
+          <a:prstGeom prst="roundRect">
+            <a:avLst>
+              <a:gd name="adj" fmla="val 13333"/>
+            </a:avLst>
+          </a:prstGeom>
+          <a:solidFill>
+            <a:srgbClr val="EEF2FF"/>
+          </a:solidFill>
+          <a:ln w="12700">
+            <a:solidFill>
+              <a:srgbClr val="C7D2FE"/>
+            </a:solidFill>
+            <a:prstDash val="solid"/>
+          </a:ln>
+        </p:spPr>
+      </p:sp>
+      <p:sp>
+        <p:nvSpPr>
+          <p:cNvPr id="7" name="Text 5"/>
+          <p:cNvSpPr txBox="1"/>
+          <p:nvPr/>
+        </p:nvSpPr>
+        <p:spPr>
+          <a:xfrm>
+            <a:off x="777240" y="2606040"/>
+            <a:ext cx="7680960" cy="548640"/>
+          </a:xfrm>
+          <a:prstGeom prst="rect">
+            <a:avLst/>
+          </a:prstGeom>
+          <a:noFill/>
+          <a:ln/>
+        </p:spPr>
+        <p:txBody>
+          <a:bodyPr wrap="square" lIns="0" tIns="0" rIns="0" bIns="0" rtlCol="0" anchor="ctr">
+            <a:normAutofit/>
+          </a:bodyPr>
+          <a:lstStyle/>
+          <a:p>
+            <a:pPr indent="0" marL="0">
+              <a:buNone/>
+            </a:pPr>
+            <a:r>
+              <a:rPr lang="en-US" sz="1800" dirty="0">
+                <a:solidFill>
+                  <a:srgbClr val="1F2937"/>
+                </a:solidFill>
+              </a:rPr>
+              <a:t>B)  Os dados de entrada</a:t>
+            </a:r>
+            <a:endParaRPr lang="en-US" sz="1800" dirty="0"/>
+          </a:p>
+        </p:txBody>
+      </p:sp>
+      <p:sp>
+        <p:nvSpPr>
+          <p:cNvPr id="8" name="Shape 6"/>
+          <p:cNvSpPr/>
+          <p:nvPr/>
+        </p:nvSpPr>
+        <p:spPr>
+          <a:xfrm>
+            <a:off x="548640" y="3246120"/>
+            <a:ext cx="8046720" cy="548640"/>
+          </a:xfrm>
+          <a:prstGeom prst="roundRect">
+            <a:avLst>
+              <a:gd name="adj" fmla="val 13333"/>
+            </a:avLst>
+          </a:prstGeom>
+          <a:solidFill>
+            <a:srgbClr val="EEF2FF"/>
+          </a:solidFill>
+          <a:ln w="12700">
+            <a:solidFill>
+              <a:srgbClr val="C7D2FE"/>
+            </a:solidFill>
+            <a:prstDash val="solid"/>
+          </a:ln>
+        </p:spPr>
+      </p:sp>
+      <p:sp>
+        <p:nvSpPr>
+          <p:cNvPr id="9" name="Text 7"/>
+          <p:cNvSpPr txBox="1"/>
+          <p:nvPr/>
+        </p:nvSpPr>
+        <p:spPr>
+          <a:xfrm>
+            <a:off x="777240" y="3246120"/>
+            <a:ext cx="7680960" cy="548640"/>
+          </a:xfrm>
+          <a:prstGeom prst="rect">
+            <a:avLst/>
+          </a:prstGeom>
+          <a:noFill/>
+          <a:ln/>
+        </p:spPr>
+        <p:txBody>
+          <a:bodyPr wrap="square" lIns="0" tIns="0" rIns="0" bIns="0" rtlCol="0" anchor="ctr">
+            <a:normAutofit/>
+          </a:bodyPr>
+          <a:lstStyle/>
+          <a:p>
+            <a:pPr indent="0" marL="0">
+              <a:buNone/>
+            </a:pPr>
+            <a:r>
+              <a:rPr lang="en-US" sz="1800" dirty="0">
+                <a:solidFill>
+                  <a:srgbClr val="1F2937"/>
+                </a:solidFill>
+              </a:rPr>
+              <a:t>C)  O número de amostras</a:t>
+            </a:r>
+            <a:endParaRPr lang="en-US" sz="1800" dirty="0"/>
+          </a:p>
+        </p:txBody>
+      </p:sp>
+      <p:sp>
+        <p:nvSpPr>
+          <p:cNvPr id="10" name="Shape 8"/>
+          <p:cNvSpPr/>
+          <p:nvPr/>
+        </p:nvSpPr>
+        <p:spPr>
+          <a:xfrm>
+            <a:off x="548640" y="3886200"/>
+            <a:ext cx="8046720" cy="548640"/>
+          </a:xfrm>
+          <a:prstGeom prst="roundRect">
+            <a:avLst>
+              <a:gd name="adj" fmla="val 13333"/>
+            </a:avLst>
+          </a:prstGeom>
+          <a:solidFill>
+            <a:srgbClr val="EEF2FF"/>
+          </a:solidFill>
+          <a:ln w="12700">
+            <a:solidFill>
+              <a:srgbClr val="C7D2FE"/>
+            </a:solidFill>
+            <a:prstDash val="solid"/>
+          </a:ln>
+        </p:spPr>
+      </p:sp>
+      <p:sp>
+        <p:nvSpPr>
+          <p:cNvPr id="11" name="Text 9"/>
+          <p:cNvSpPr txBox="1"/>
+          <p:nvPr/>
+        </p:nvSpPr>
+        <p:spPr>
+          <a:xfrm>
+            <a:off x="777240" y="3886200"/>
+            <a:ext cx="7680960" cy="548640"/>
+          </a:xfrm>
+          <a:prstGeom prst="rect">
+            <a:avLst/>
+          </a:prstGeom>
+          <a:noFill/>
+          <a:ln/>
+        </p:spPr>
+        <p:txBody>
+          <a:bodyPr wrap="square" lIns="0" tIns="0" rIns="0" bIns="0" rtlCol="0" anchor="ctr">
+            <a:normAutofit/>
+          </a:bodyPr>
+          <a:lstStyle/>
+          <a:p>
+            <a:pPr indent="0" marL="0">
+              <a:buNone/>
+            </a:pPr>
+            <a:r>
+              <a:rPr lang="en-US" sz="1800" dirty="0">
+                <a:solidFill>
+                  <a:srgbClr val="1F2937"/>
+                </a:solidFill>
+              </a:rPr>
+              <a:t>D)  A taxa de aprendizagem</a:t>
+            </a:r>
+            <a:endParaRPr lang="en-US" sz="1800" dirty="0"/>
+          </a:p>
+        </p:txBody>
+      </p:sp>
+      <p:sp>
+        <p:nvSpPr>
+          <p:cNvPr id="25" name="Slide Number Placeholder 0"/>
+          <p:cNvSpPr>
+            <a:spLocks noGrp="1"/>
+          </p:cNvSpPr>
+          <p:nvPr>
+            <p:ph type="sldNum" sz="quarter" idx="4294967295"/>
+          </p:nvPr>
+        </p:nvSpPr>
+        <p:spPr>
+          <a:xfrm>
+            <a:off x="8412480" y="4828032"/>
+            <a:ext cx="457200" cy="228600"/>
+          </a:xfrm>
+          <a:prstGeom prst="rect">
+            <a:avLst/>
+          </a:prstGeom>
+          <a:extLst>
+            <a:ext uri="{C572A759-6A51-4108-AA02-DFA0A04FC94B}">
+              <ma14:wrappingTextBoxFlag xmlns:ma14="http://schemas.microsoft.com/office/mac/drawingml/2011/main" val="0"/>
+            </a:ext>
+          </a:extLst>
+        </p:spPr>
+        <p:txBody>
+          <a:bodyPr/>
+          <a:lstStyle>
+            <a:lvl1pPr>
+              <a:defRPr sz="900">
+                <a:solidFill>
+                  <a:srgbClr val="6B7280"/>
+                </a:solidFill>
+              </a:defRPr>
+            </a:lvl1pPr>
+          </a:lstStyle>
+          <a:p>
+            <a:pPr algn="l"/>
+            <a:fld id="{F7021451-1387-4CA6-816F-3879F97B5CBC}" type="slidenum">
+              <a:rPr b="0" lang="en-US"/>
+              <a:t>14</a:t>
+            </a:fld>
+            <a:endParaRPr lang="en-US"/>
+          </a:p>
+        </p:txBody>
+      </p:sp>
+    </p:spTree>
+  </p:cSld>
+  <p:clrMapOvr>
+    <a:masterClrMapping/>
+  </p:clrMapOvr>
+</p:sld>
+</file>
+
+<file path=ppt/slides/slide15.xml><?xml version="1.0" encoding="utf-8"?>
+<p:sld xmlns:a="http://schemas.openxmlformats.org/drawingml/2006/main" xmlns:r="http://schemas.openxmlformats.org/officeDocument/2006/relationships" xmlns:p="http://schemas.openxmlformats.org/presentationml/2006/main">
+  <p:cSld name="Slide 15">
+    <p:spTree>
+      <p:nvGrpSpPr>
+        <p:cNvPr id="1" name=""/>
+        <p:cNvGrpSpPr/>
+        <p:nvPr/>
+      </p:nvGrpSpPr>
+      <p:grpSpPr>
+        <a:xfrm>
+          <a:off x="0" y="0"/>
+          <a:ext cx="0" cy="0"/>
+          <a:chOff x="0" y="0"/>
+          <a:chExt cx="0" cy="0"/>
+        </a:xfrm>
+      </p:grpSpPr>
+      <p:sp>
+        <p:nvSpPr>
+          <p:cNvPr id="2" name="Text 0"/>
+          <p:cNvSpPr txBox="1"/>
+          <p:nvPr/>
+        </p:nvSpPr>
+        <p:spPr>
+          <a:xfrm>
+            <a:off x="365760" y="109728"/>
+            <a:ext cx="8412480" cy="658368"/>
+          </a:xfrm>
+          <a:prstGeom prst="rect">
+            <a:avLst/>
+          </a:prstGeom>
+          <a:noFill/>
+          <a:ln/>
+        </p:spPr>
+        <p:txBody>
+          <a:bodyPr wrap="square" lIns="0" tIns="0" rIns="0" bIns="0" rtlCol="0" anchor="ctr">
+            <a:normAutofit/>
+          </a:bodyPr>
+          <a:lstStyle/>
+          <a:p>
+            <a:pPr indent="0" marL="0">
+              <a:buNone/>
+            </a:pPr>
+            <a:r>
+              <a:rPr lang="en-US" sz="2600" b="1" dirty="0">
+                <a:solidFill>
+                  <a:srgbClr val="FFFFFF"/>
+                </a:solidFill>
+                <a:latin typeface="Calibri" pitchFamily="34" charset="0"/>
+                <a:ea typeface="Calibri" pitchFamily="34" charset="-122"/>
+                <a:cs typeface="Calibri" pitchFamily="34" charset="-120"/>
+              </a:rPr>
+              <a:t>Quiz relâmpago 2</a:t>
+            </a:r>
+            <a:endParaRPr lang="en-US" sz="2600" dirty="0"/>
+          </a:p>
+        </p:txBody>
+      </p:sp>
+      <p:sp>
+        <p:nvSpPr>
+          <p:cNvPr id="3" name="Text 1"/>
+          <p:cNvSpPr txBox="1"/>
+          <p:nvPr/>
+        </p:nvSpPr>
+        <p:spPr>
+          <a:xfrm>
+            <a:off x="548640" y="1051560"/>
+            <a:ext cx="8046720" cy="822960"/>
+          </a:xfrm>
+          <a:prstGeom prst="rect">
+            <a:avLst/>
+          </a:prstGeom>
+          <a:noFill/>
+          <a:ln/>
+        </p:spPr>
+        <p:txBody>
+          <a:bodyPr wrap="square" lIns="0" tIns="0" rIns="0" bIns="0" rtlCol="0" anchor="ctr">
+            <a:normAutofit/>
+          </a:bodyPr>
+          <a:lstStyle/>
+          <a:p>
+            <a:pPr indent="0" marL="0">
+              <a:buNone/>
+            </a:pPr>
+            <a:r>
+              <a:rPr lang="en-US" sz="2200" b="1" dirty="0">
+                <a:solidFill>
+                  <a:srgbClr val="312E81"/>
+                </a:solidFill>
+              </a:rPr>
+              <a:t>Qual conjunto só deve ser usado no fim, para relatar o desempenho?</a:t>
+            </a:r>
+            <a:endParaRPr lang="en-US" sz="2200" dirty="0"/>
+          </a:p>
+        </p:txBody>
+      </p:sp>
+      <p:sp>
+        <p:nvSpPr>
+          <p:cNvPr id="4" name="Shape 2"/>
+          <p:cNvSpPr/>
+          <p:nvPr/>
+        </p:nvSpPr>
+        <p:spPr>
+          <a:xfrm>
+            <a:off x="548640" y="1965960"/>
+            <a:ext cx="8046720" cy="548640"/>
+          </a:xfrm>
+          <a:prstGeom prst="roundRect">
+            <a:avLst>
+              <a:gd name="adj" fmla="val 13333"/>
+            </a:avLst>
+          </a:prstGeom>
+          <a:solidFill>
+            <a:srgbClr val="EEF2FF"/>
+          </a:solidFill>
+          <a:ln w="12700">
+            <a:solidFill>
+              <a:srgbClr val="C7D2FE"/>
+            </a:solidFill>
+            <a:prstDash val="solid"/>
+          </a:ln>
+        </p:spPr>
+      </p:sp>
+      <p:sp>
+        <p:nvSpPr>
+          <p:cNvPr id="5" name="Text 3"/>
+          <p:cNvSpPr txBox="1"/>
+          <p:nvPr/>
+        </p:nvSpPr>
+        <p:spPr>
+          <a:xfrm>
+            <a:off x="777240" y="1965960"/>
+            <a:ext cx="7680960" cy="548640"/>
+          </a:xfrm>
+          <a:prstGeom prst="rect">
+            <a:avLst/>
+          </a:prstGeom>
+          <a:noFill/>
+          <a:ln/>
+        </p:spPr>
+        <p:txBody>
+          <a:bodyPr wrap="square" lIns="0" tIns="0" rIns="0" bIns="0" rtlCol="0" anchor="ctr">
+            <a:normAutofit/>
+          </a:bodyPr>
+          <a:lstStyle/>
+          <a:p>
+            <a:pPr indent="0" marL="0">
+              <a:buNone/>
+            </a:pPr>
+            <a:r>
+              <a:rPr lang="en-US" sz="1800" dirty="0">
+                <a:solidFill>
+                  <a:srgbClr val="1F2937"/>
+                </a:solidFill>
+              </a:rPr>
+              <a:t>A)  Treino</a:t>
+            </a:r>
+            <a:endParaRPr lang="en-US" sz="1800" dirty="0"/>
+          </a:p>
+        </p:txBody>
+      </p:sp>
+      <p:sp>
+        <p:nvSpPr>
+          <p:cNvPr id="6" name="Shape 4"/>
+          <p:cNvSpPr/>
+          <p:nvPr/>
+        </p:nvSpPr>
+        <p:spPr>
+          <a:xfrm>
+            <a:off x="548640" y="2606040"/>
+            <a:ext cx="8046720" cy="548640"/>
+          </a:xfrm>
+          <a:prstGeom prst="roundRect">
+            <a:avLst>
+              <a:gd name="adj" fmla="val 13333"/>
+            </a:avLst>
+          </a:prstGeom>
+          <a:solidFill>
+            <a:srgbClr val="EEF2FF"/>
+          </a:solidFill>
+          <a:ln w="12700">
+            <a:solidFill>
+              <a:srgbClr val="C7D2FE"/>
+            </a:solidFill>
+            <a:prstDash val="solid"/>
+          </a:ln>
+        </p:spPr>
+      </p:sp>
+      <p:sp>
+        <p:nvSpPr>
+          <p:cNvPr id="7" name="Text 5"/>
+          <p:cNvSpPr txBox="1"/>
+          <p:nvPr/>
+        </p:nvSpPr>
+        <p:spPr>
+          <a:xfrm>
+            <a:off x="777240" y="2606040"/>
+            <a:ext cx="7680960" cy="548640"/>
+          </a:xfrm>
+          <a:prstGeom prst="rect">
+            <a:avLst/>
+          </a:prstGeom>
+          <a:noFill/>
+          <a:ln/>
+        </p:spPr>
+        <p:txBody>
+          <a:bodyPr wrap="square" lIns="0" tIns="0" rIns="0" bIns="0" rtlCol="0" anchor="ctr">
+            <a:normAutofit/>
+          </a:bodyPr>
+          <a:lstStyle/>
+          <a:p>
+            <a:pPr indent="0" marL="0">
+              <a:buNone/>
+            </a:pPr>
+            <a:r>
+              <a:rPr lang="en-US" sz="1800" dirty="0">
+                <a:solidFill>
+                  <a:srgbClr val="1F2937"/>
+                </a:solidFill>
+              </a:rPr>
+              <a:t>B)  Validação</a:t>
+            </a:r>
+            <a:endParaRPr lang="en-US" sz="1800" dirty="0"/>
+          </a:p>
+        </p:txBody>
+      </p:sp>
+      <p:sp>
+        <p:nvSpPr>
+          <p:cNvPr id="8" name="Shape 6"/>
+          <p:cNvSpPr/>
+          <p:nvPr/>
+        </p:nvSpPr>
+        <p:spPr>
+          <a:xfrm>
+            <a:off x="548640" y="3246120"/>
+            <a:ext cx="8046720" cy="548640"/>
+          </a:xfrm>
+          <a:prstGeom prst="roundRect">
+            <a:avLst>
+              <a:gd name="adj" fmla="val 13333"/>
+            </a:avLst>
+          </a:prstGeom>
+          <a:solidFill>
+            <a:srgbClr val="EEF2FF"/>
+          </a:solidFill>
+          <a:ln w="12700">
+            <a:solidFill>
+              <a:srgbClr val="C7D2FE"/>
+            </a:solidFill>
+            <a:prstDash val="solid"/>
+          </a:ln>
+        </p:spPr>
+      </p:sp>
+      <p:sp>
+        <p:nvSpPr>
+          <p:cNvPr id="9" name="Text 7"/>
+          <p:cNvSpPr txBox="1"/>
+          <p:nvPr/>
+        </p:nvSpPr>
+        <p:spPr>
+          <a:xfrm>
+            <a:off x="777240" y="3246120"/>
+            <a:ext cx="7680960" cy="548640"/>
+          </a:xfrm>
+          <a:prstGeom prst="rect">
+            <a:avLst/>
+          </a:prstGeom>
+          <a:noFill/>
+          <a:ln/>
+        </p:spPr>
+        <p:txBody>
+          <a:bodyPr wrap="square" lIns="0" tIns="0" rIns="0" bIns="0" rtlCol="0" anchor="ctr">
+            <a:normAutofit/>
+          </a:bodyPr>
+          <a:lstStyle/>
+          <a:p>
+            <a:pPr indent="0" marL="0">
+              <a:buNone/>
+            </a:pPr>
+            <a:r>
+              <a:rPr lang="en-US" sz="1800" dirty="0">
+                <a:solidFill>
+                  <a:srgbClr val="1F2937"/>
+                </a:solidFill>
+              </a:rPr>
+              <a:t>C)  Teste</a:t>
+            </a:r>
+            <a:endParaRPr lang="en-US" sz="1800" dirty="0"/>
+          </a:p>
+        </p:txBody>
+      </p:sp>
+      <p:sp>
+        <p:nvSpPr>
+          <p:cNvPr id="10" name="Shape 8"/>
+          <p:cNvSpPr/>
+          <p:nvPr/>
+        </p:nvSpPr>
+        <p:spPr>
+          <a:xfrm>
+            <a:off x="548640" y="3886200"/>
+            <a:ext cx="8046720" cy="548640"/>
+          </a:xfrm>
+          <a:prstGeom prst="roundRect">
+            <a:avLst>
+              <a:gd name="adj" fmla="val 13333"/>
+            </a:avLst>
+          </a:prstGeom>
+          <a:solidFill>
+            <a:srgbClr val="EEF2FF"/>
+          </a:solidFill>
+          <a:ln w="12700">
+            <a:solidFill>
+              <a:srgbClr val="C7D2FE"/>
+            </a:solidFill>
+            <a:prstDash val="solid"/>
+          </a:ln>
+        </p:spPr>
+      </p:sp>
+      <p:sp>
+        <p:nvSpPr>
+          <p:cNvPr id="11" name="Text 9"/>
+          <p:cNvSpPr txBox="1"/>
+          <p:nvPr/>
+        </p:nvSpPr>
+        <p:spPr>
+          <a:xfrm>
+            <a:off x="777240" y="3886200"/>
+            <a:ext cx="7680960" cy="548640"/>
+          </a:xfrm>
+          <a:prstGeom prst="rect">
+            <a:avLst/>
+          </a:prstGeom>
+          <a:noFill/>
+          <a:ln/>
+        </p:spPr>
+        <p:txBody>
+          <a:bodyPr wrap="square" lIns="0" tIns="0" rIns="0" bIns="0" rtlCol="0" anchor="ctr">
+            <a:normAutofit/>
+          </a:bodyPr>
+          <a:lstStyle/>
+          <a:p>
+            <a:pPr indent="0" marL="0">
+              <a:buNone/>
+            </a:pPr>
+            <a:r>
+              <a:rPr lang="en-US" sz="1800" dirty="0">
+                <a:solidFill>
+                  <a:srgbClr val="1F2937"/>
+                </a:solidFill>
+              </a:rPr>
+              <a:t>D)  Qualquer um deles</a:t>
+            </a:r>
+            <a:endParaRPr lang="en-US" sz="1800" dirty="0"/>
+          </a:p>
+        </p:txBody>
+      </p:sp>
+      <p:sp>
+        <p:nvSpPr>
+          <p:cNvPr id="25" name="Slide Number Placeholder 0"/>
+          <p:cNvSpPr>
+            <a:spLocks noGrp="1"/>
+          </p:cNvSpPr>
+          <p:nvPr>
+            <p:ph type="sldNum" sz="quarter" idx="4294967295"/>
+          </p:nvPr>
+        </p:nvSpPr>
+        <p:spPr>
+          <a:xfrm>
+            <a:off x="8412480" y="4828032"/>
+            <a:ext cx="457200" cy="228600"/>
+          </a:xfrm>
+          <a:prstGeom prst="rect">
+            <a:avLst/>
+          </a:prstGeom>
+          <a:extLst>
+            <a:ext uri="{C572A759-6A51-4108-AA02-DFA0A04FC94B}">
+              <ma14:wrappingTextBoxFlag xmlns:ma14="http://schemas.microsoft.com/office/mac/drawingml/2011/main" val="0"/>
+            </a:ext>
+          </a:extLst>
+        </p:spPr>
+        <p:txBody>
+          <a:bodyPr/>
+          <a:lstStyle>
+            <a:lvl1pPr>
+              <a:defRPr sz="900">
+                <a:solidFill>
+                  <a:srgbClr val="6B7280"/>
+                </a:solidFill>
+              </a:defRPr>
+            </a:lvl1pPr>
+          </a:lstStyle>
+          <a:p>
+            <a:pPr algn="l"/>
+            <a:fld id="{F7021451-1387-4CA6-816F-3879F97B5CBC}" type="slidenum">
+              <a:rPr b="0" lang="en-US"/>
+              <a:t>15</a:t>
+            </a:fld>
+            <a:endParaRPr lang="en-US"/>
+          </a:p>
+        </p:txBody>
+      </p:sp>
+    </p:spTree>
+  </p:cSld>
+  <p:clrMapOvr>
+    <a:masterClrMapping/>
+  </p:clrMapOvr>
+</p:sld>
+</file>
+
+<file path=ppt/slides/slide16.xml><?xml version="1.0" encoding="utf-8"?>
+<p:sld xmlns:a="http://schemas.openxmlformats.org/drawingml/2006/main" xmlns:r="http://schemas.openxmlformats.org/officeDocument/2006/relationships" xmlns:p="http://schemas.openxmlformats.org/presentationml/2006/main">
+  <p:cSld name="Slide 16">
+    <p:spTree>
+      <p:nvGrpSpPr>
+        <p:cNvPr id="1" name=""/>
+        <p:cNvGrpSpPr/>
+        <p:nvPr/>
+      </p:nvGrpSpPr>
+      <p:grpSpPr>
+        <a:xfrm>
+          <a:off x="0" y="0"/>
+          <a:ext cx="0" cy="0"/>
+          <a:chOff x="0" y="0"/>
+          <a:chExt cx="0" cy="0"/>
+        </a:xfrm>
+      </p:grpSpPr>
+      <p:sp>
+        <p:nvSpPr>
+          <p:cNvPr id="2" name="Text 0"/>
+          <p:cNvSpPr txBox="1"/>
+          <p:nvPr/>
+        </p:nvSpPr>
+        <p:spPr>
+          <a:xfrm>
+            <a:off x="365760" y="109728"/>
+            <a:ext cx="8412480" cy="658368"/>
+          </a:xfrm>
+          <a:prstGeom prst="rect">
+            <a:avLst/>
+          </a:prstGeom>
+          <a:noFill/>
+          <a:ln/>
+        </p:spPr>
+        <p:txBody>
+          <a:bodyPr wrap="square" lIns="0" tIns="0" rIns="0" bIns="0" rtlCol="0" anchor="ctr">
+            <a:normAutofit/>
+          </a:bodyPr>
+          <a:lstStyle/>
+          <a:p>
+            <a:pPr indent="0" marL="0">
+              <a:buNone/>
+            </a:pPr>
+            <a:r>
+              <a:rPr lang="en-US" sz="2600" b="1" dirty="0">
+                <a:solidFill>
+                  <a:srgbClr val="FFFFFF"/>
+                </a:solidFill>
+                <a:latin typeface="Calibri" pitchFamily="34" charset="0"/>
+                <a:ea typeface="Calibri" pitchFamily="34" charset="-122"/>
+                <a:cs typeface="Calibri" pitchFamily="34" charset="-120"/>
+              </a:rPr>
+              <a:t>Atividade</a:t>
+            </a:r>
+            <a:endParaRPr lang="en-US" sz="2600" dirty="0"/>
+          </a:p>
+        </p:txBody>
+      </p:sp>
+      <p:sp>
+        <p:nvSpPr>
+          <p:cNvPr id="3" name="Shape 1"/>
+          <p:cNvSpPr/>
+          <p:nvPr/>
+        </p:nvSpPr>
+        <p:spPr>
+          <a:xfrm>
+            <a:off x="548640" y="1188720"/>
+            <a:ext cx="8046720" cy="3108960"/>
+          </a:xfrm>
+          <a:prstGeom prst="roundRect">
+            <a:avLst>
+              <a:gd name="adj" fmla="val 3529"/>
+            </a:avLst>
+          </a:prstGeom>
+          <a:solidFill>
+            <a:srgbClr val="FFFBEB"/>
+          </a:solidFill>
+          <a:ln w="25400">
+            <a:solidFill>
+              <a:srgbClr val="F59E0B"/>
+            </a:solidFill>
+            <a:prstDash val="solid"/>
+          </a:ln>
+        </p:spPr>
+      </p:sp>
+      <p:sp>
+        <p:nvSpPr>
+          <p:cNvPr id="4" name="Text 2"/>
+          <p:cNvSpPr txBox="1"/>
+          <p:nvPr/>
+        </p:nvSpPr>
+        <p:spPr>
+          <a:xfrm>
+            <a:off x="822960" y="1325880"/>
+            <a:ext cx="3657600" cy="365760"/>
+          </a:xfrm>
+          <a:prstGeom prst="rect">
+            <a:avLst/>
+          </a:prstGeom>
+          <a:noFill/>
+          <a:ln/>
+        </p:spPr>
+        <p:txBody>
+          <a:bodyPr wrap="square" lIns="0" tIns="0" rIns="0" bIns="0" rtlCol="0" anchor="ctr"/>
+          <a:lstStyle/>
+          <a:p>
+            <a:pPr indent="0" marL="0">
+              <a:buNone/>
+            </a:pPr>
+            <a:r>
+              <a:rPr lang="en-US" sz="1400" b="1" spc="300" kern="0" dirty="0">
+                <a:solidFill>
+                  <a:srgbClr val="B45309"/>
+                </a:solidFill>
+              </a:rPr>
+              <a:t>MÃO NA MASSA</a:t>
+            </a:r>
+            <a:endParaRPr lang="en-US" sz="1400" dirty="0"/>
+          </a:p>
+        </p:txBody>
+      </p:sp>
+      <p:sp>
+        <p:nvSpPr>
+          <p:cNvPr id="5" name="Text 3"/>
+          <p:cNvSpPr txBox="1"/>
+          <p:nvPr/>
+        </p:nvSpPr>
+        <p:spPr>
+          <a:xfrm>
+            <a:off x="822960" y="1783080"/>
+            <a:ext cx="7498080" cy="2377440"/>
+          </a:xfrm>
+          <a:prstGeom prst="rect">
+            <a:avLst/>
+          </a:prstGeom>
+          <a:noFill/>
+          <a:ln/>
+        </p:spPr>
+        <p:txBody>
+          <a:bodyPr wrap="square" lIns="0" tIns="0" rIns="0" bIns="0" rtlCol="0" anchor="t">
+            <a:normAutofit/>
+          </a:bodyPr>
+          <a:lstStyle/>
+          <a:p>
+            <a:pPr indent="0" marL="0">
+              <a:buNone/>
+            </a:pPr>
+            <a:r>
+              <a:rPr lang="en-US" sz="2100" dirty="0">
+                <a:solidFill>
+                  <a:srgbClr val="1F2937"/>
+                </a:solidFill>
+              </a:rPr>
+              <a:t>Treine uma rede 1–8–1 em dados sintéticos com três sementes diferentes. Anote o erro final de cada uma. O que a variação entre sementes sugere sobre como relatar resultados?</a:t>
+            </a:r>
+            <a:endParaRPr lang="en-US" sz="2100" dirty="0"/>
+          </a:p>
+        </p:txBody>
+      </p:sp>
+      <p:sp>
+        <p:nvSpPr>
+          <p:cNvPr id="25" name="Slide Number Placeholder 0"/>
+          <p:cNvSpPr>
+            <a:spLocks noGrp="1"/>
+          </p:cNvSpPr>
+          <p:nvPr>
+            <p:ph type="sldNum" sz="quarter" idx="4294967295"/>
+          </p:nvPr>
+        </p:nvSpPr>
+        <p:spPr>
+          <a:xfrm>
+            <a:off x="8412480" y="4828032"/>
+            <a:ext cx="457200" cy="228600"/>
+          </a:xfrm>
+          <a:prstGeom prst="rect">
+            <a:avLst/>
+          </a:prstGeom>
+          <a:extLst>
+            <a:ext uri="{C572A759-6A51-4108-AA02-DFA0A04FC94B}">
+              <ma14:wrappingTextBoxFlag xmlns:ma14="http://schemas.microsoft.com/office/mac/drawingml/2011/main" val="0"/>
+            </a:ext>
+          </a:extLst>
+        </p:spPr>
+        <p:txBody>
+          <a:bodyPr/>
+          <a:lstStyle>
+            <a:lvl1pPr>
+              <a:defRPr sz="900">
+                <a:solidFill>
+                  <a:srgbClr val="6B7280"/>
+                </a:solidFill>
+              </a:defRPr>
+            </a:lvl1pPr>
+          </a:lstStyle>
+          <a:p>
+            <a:pPr algn="l"/>
+            <a:fld id="{F7021451-1387-4CA6-816F-3879F97B5CBC}" type="slidenum">
+              <a:rPr b="0" lang="en-US"/>
+              <a:t>16</a:t>
+            </a:fld>
+            <a:endParaRPr lang="en-US"/>
+          </a:p>
+        </p:txBody>
+      </p:sp>
+    </p:spTree>
+  </p:cSld>
+  <p:clrMapOvr>
+    <a:masterClrMapping/>
+  </p:clrMapOvr>
+</p:sld>
+</file>
+
+<file path=ppt/slides/slide17.xml><?xml version="1.0" encoding="utf-8"?>
+<p:sld xmlns:a="http://schemas.openxmlformats.org/drawingml/2006/main" xmlns:r="http://schemas.openxmlformats.org/officeDocument/2006/relationships" xmlns:p="http://schemas.openxmlformats.org/presentationml/2006/main">
+  <p:cSld name="Slide 17">
+    <p:spTree>
+      <p:nvGrpSpPr>
+        <p:cNvPr id="1" name=""/>
+        <p:cNvGrpSpPr/>
+        <p:nvPr/>
+      </p:nvGrpSpPr>
+      <p:grpSpPr>
+        <a:xfrm>
+          <a:off x="0" y="0"/>
+          <a:ext cx="0" cy="0"/>
+          <a:chOff x="0" y="0"/>
+          <a:chExt cx="0" cy="0"/>
+        </a:xfrm>
+      </p:grpSpPr>
+      <p:sp>
+        <p:nvSpPr>
+          <p:cNvPr id="2" name="Text 0"/>
+          <p:cNvSpPr txBox="1"/>
+          <p:nvPr/>
+        </p:nvSpPr>
+        <p:spPr>
+          <a:xfrm>
             <a:off x="640080" y="457200"/>
             <a:ext cx="7863840" cy="731520"/>
           </a:xfrm>
@@ -2801,6 +4740,130 @@
               <a:t>Avaliar sempre em dados não vistos</a:t>
             </a:r>
             <a:endParaRPr lang="en-US" sz="2200" dirty="0"/>
+          </a:p>
+        </p:txBody>
+      </p:sp>
+    </p:spTree>
+  </p:cSld>
+  <p:clrMapOvr>
+    <a:masterClrMapping/>
+  </p:clrMapOvr>
+</p:sld>
+</file>
+
+<file path=ppt/slides/slide18.xml><?xml version="1.0" encoding="utf-8"?>
+<p:sld xmlns:a="http://schemas.openxmlformats.org/drawingml/2006/main" xmlns:r="http://schemas.openxmlformats.org/officeDocument/2006/relationships" xmlns:p="http://schemas.openxmlformats.org/presentationml/2006/main">
+  <p:cSld name="Slide 18">
+    <p:spTree>
+      <p:nvGrpSpPr>
+        <p:cNvPr id="1" name=""/>
+        <p:cNvGrpSpPr/>
+        <p:nvPr/>
+      </p:nvGrpSpPr>
+      <p:grpSpPr>
+        <a:xfrm>
+          <a:off x="0" y="0"/>
+          <a:ext cx="0" cy="0"/>
+          <a:chOff x="0" y="0"/>
+          <a:chExt cx="0" cy="0"/>
+        </a:xfrm>
+      </p:grpSpPr>
+      <p:sp>
+        <p:nvSpPr>
+          <p:cNvPr id="2" name="Shape 0"/>
+          <p:cNvSpPr/>
+          <p:nvPr/>
+        </p:nvSpPr>
+        <p:spPr>
+          <a:xfrm>
+            <a:off x="640080" y="1188720"/>
+            <a:ext cx="109728" cy="2194560"/>
+          </a:xfrm>
+          <a:prstGeom prst="rect">
+            <a:avLst/>
+          </a:prstGeom>
+          <a:solidFill>
+            <a:srgbClr val="F59E0B"/>
+          </a:solidFill>
+          <a:ln w="12700">
+            <a:solidFill>
+              <a:srgbClr val="F59E0B"/>
+            </a:solidFill>
+            <a:prstDash val="solid"/>
+          </a:ln>
+        </p:spPr>
+      </p:sp>
+      <p:sp>
+        <p:nvSpPr>
+          <p:cNvPr id="3" name="Text 1"/>
+          <p:cNvSpPr txBox="1"/>
+          <p:nvPr/>
+        </p:nvSpPr>
+        <p:spPr>
+          <a:xfrm>
+            <a:off x="1005840" y="1097280"/>
+            <a:ext cx="7498080" cy="2377440"/>
+          </a:xfrm>
+          <a:prstGeom prst="rect">
+            <a:avLst/>
+          </a:prstGeom>
+          <a:noFill/>
+          <a:ln/>
+        </p:spPr>
+        <p:txBody>
+          <a:bodyPr wrap="square" lIns="0" tIns="0" rIns="0" bIns="0" rtlCol="0" anchor="ctr">
+            <a:normAutofit/>
+          </a:bodyPr>
+          <a:lstStyle/>
+          <a:p>
+            <a:pPr indent="0" marL="0">
+              <a:buNone/>
+            </a:pPr>
+            <a:r>
+              <a:rPr lang="en-US" sz="3400" b="1" dirty="0">
+                <a:solidFill>
+                  <a:srgbClr val="FFFFFF"/>
+                </a:solidFill>
+              </a:rPr>
+              <a:t>“Aprender é errar menos, de forma sistemática.”</a:t>
+            </a:r>
+            <a:endParaRPr lang="en-US" sz="3400" dirty="0"/>
+          </a:p>
+        </p:txBody>
+      </p:sp>
+      <p:sp>
+        <p:nvSpPr>
+          <p:cNvPr id="4" name="Text 2"/>
+          <p:cNvSpPr txBox="1"/>
+          <p:nvPr/>
+        </p:nvSpPr>
+        <p:spPr>
+          <a:xfrm>
+            <a:off x="1005840" y="3931920"/>
+            <a:ext cx="7315200" cy="365760"/>
+          </a:xfrm>
+          <a:prstGeom prst="rect">
+            <a:avLst/>
+          </a:prstGeom>
+          <a:noFill/>
+          <a:ln/>
+        </p:spPr>
+        <p:txBody>
+          <a:bodyPr wrap="square" lIns="0" tIns="0" rIns="0" bIns="0" rtlCol="0" anchor="ctr"/>
+          <a:lstStyle/>
+          <a:p>
+            <a:pPr indent="0" marL="0">
+              <a:buNone/>
+            </a:pPr>
+            <a:r>
+              <a:rPr lang="en-US" sz="1400" dirty="0">
+                <a:solidFill>
+                  <a:srgbClr val="A5B4FC"/>
+                </a:solidFill>
+              </a:rPr>
+              <a:t>Backpropagation e Redes Neurais · Capítulo 1</a:t>
+            </a:r>
+            <a:endParaRPr lang="en-US" sz="1400" dirty="0"/>
           </a:p>
         </p:txBody>
       </p:sp>
@@ -2864,7 +4927,7 @@
                 <a:ea typeface="Calibri" pitchFamily="34" charset="-122"/>
                 <a:cs typeface="Calibri" pitchFamily="34" charset="-120"/>
               </a:rPr>
-              <a:t>Situação inicial: como uma máquina aprende?</a:t>
+              <a:t>Roteiro da aula</a:t>
             </a:r>
             <a:endParaRPr lang="en-US" sz="2600" dirty="0"/>
           </a:p>
@@ -2878,8 +4941,8 @@
         </p:nvSpPr>
         <p:spPr>
           <a:xfrm>
-            <a:off x="548640" y="1188720"/>
-            <a:ext cx="8046720" cy="3383280"/>
+            <a:off x="731520" y="1188720"/>
+            <a:ext cx="7680960" cy="3291840"/>
           </a:xfrm>
           <a:prstGeom prst="rect">
             <a:avLst/>
@@ -2888,63 +4951,121 @@
           <a:ln/>
         </p:spPr>
         <p:txBody>
-          <a:bodyPr wrap="square" lIns="0" tIns="0" rIns="0" bIns="0" rtlCol="0" anchor="t">
-            <a:normAutofit/>
-          </a:bodyPr>
+          <a:bodyPr wrap="square" lIns="0" tIns="0" rIns="0" bIns="0" rtlCol="0" anchor="t"/>
           <a:lstStyle/>
           <a:p>
             <a:pPr marL="342900" indent="-342900">
               <a:spcAft>
-                <a:spcPts val="1400"/>
+                <a:spcPts val="1200"/>
               </a:spcAft>
               <a:buSzPct val="100000"/>
-              <a:buChar char="•"/>
-            </a:pPr>
-            <a:r>
-              <a:rPr lang="en-US" sz="2400" dirty="0">
+              <a:buFont typeface="+mj-lt"/>
+              <a:buAutoNum type="arabicPeriod" startAt="1"/>
+            </a:pPr>
+            <a:r>
+              <a:rPr lang="en-US" sz="2200" dirty="0">
                 <a:solidFill>
                   <a:srgbClr val="1F2937"/>
                 </a:solidFill>
               </a:rPr>
-              <a:t>Ninguém programa a regra: ela é ajustada a partir de exemplos</a:t>
-            </a:r>
-            <a:endParaRPr lang="en-US" sz="2400" dirty="0"/>
+              <a:t>Situação inicial e objetivos</a:t>
+            </a:r>
+            <a:endParaRPr lang="en-US" sz="2200" dirty="0"/>
           </a:p>
           <a:p>
             <a:pPr marL="342900" indent="-342900">
               <a:spcAft>
-                <a:spcPts val="1400"/>
+                <a:spcPts val="1200"/>
               </a:spcAft>
               <a:buSzPct val="100000"/>
-              <a:buChar char="•"/>
-            </a:pPr>
-            <a:r>
-              <a:rPr lang="en-US" sz="2400" dirty="0">
+              <a:buFont typeface="+mj-lt"/>
+              <a:buAutoNum type="arabicPeriod" startAt="1"/>
+            </a:pPr>
+            <a:r>
+              <a:rPr lang="en-US" sz="2200" dirty="0">
                 <a:solidFill>
                   <a:srgbClr val="1F2937"/>
                 </a:solidFill>
               </a:rPr>
-              <a:t>Aprender = reduzir um erro medido nos dados</a:t>
-            </a:r>
-            <a:endParaRPr lang="en-US" sz="2400" dirty="0"/>
+              <a:t>Analogia do dia a dia</a:t>
+            </a:r>
+            <a:endParaRPr lang="en-US" sz="2200" dirty="0"/>
           </a:p>
           <a:p>
             <a:pPr marL="342900" indent="-342900">
               <a:spcAft>
-                <a:spcPts val="1400"/>
+                <a:spcPts val="1200"/>
               </a:spcAft>
               <a:buSzPct val="100000"/>
-              <a:buChar char="•"/>
-            </a:pPr>
-            <a:r>
-              <a:rPr lang="en-US" sz="2400" dirty="0">
+              <a:buFont typeface="+mj-lt"/>
+              <a:buAutoNum type="arabicPeriod" startAt="1"/>
+            </a:pPr>
+            <a:r>
+              <a:rPr lang="en-US" sz="2200" dirty="0">
                 <a:solidFill>
                   <a:srgbClr val="1F2937"/>
                 </a:solidFill>
               </a:rPr>
-              <a:t>Hoje: o mapa do livro e a primeira rede funcionando</a:t>
-            </a:r>
-            <a:endParaRPr lang="en-US" sz="2400" dirty="0"/>
+              <a:t>Conceitos, demonstrações e figuras</a:t>
+            </a:r>
+            <a:endParaRPr lang="en-US" sz="2200" dirty="0"/>
+          </a:p>
+          <a:p>
+            <a:pPr marL="342900" indent="-342900">
+              <a:spcAft>
+                <a:spcPts val="1200"/>
+              </a:spcAft>
+              <a:buSzPct val="100000"/>
+              <a:buFont typeface="+mj-lt"/>
+              <a:buAutoNum type="arabicPeriod" startAt="1"/>
+            </a:pPr>
+            <a:r>
+              <a:rPr lang="en-US" sz="2200" dirty="0">
+                <a:solidFill>
+                  <a:srgbClr val="1F2937"/>
+                </a:solidFill>
+              </a:rPr>
+              <a:t>Exemplos e resultados do livro</a:t>
+            </a:r>
+            <a:endParaRPr lang="en-US" sz="2200" dirty="0"/>
+          </a:p>
+          <a:p>
+            <a:pPr marL="342900" indent="-342900">
+              <a:spcAft>
+                <a:spcPts val="1200"/>
+              </a:spcAft>
+              <a:buSzPct val="100000"/>
+              <a:buFont typeface="+mj-lt"/>
+              <a:buAutoNum type="arabicPeriod" startAt="1"/>
+            </a:pPr>
+            <a:r>
+              <a:rPr lang="en-US" sz="2200" dirty="0">
+                <a:solidFill>
+                  <a:srgbClr val="1F2937"/>
+                </a:solidFill>
+              </a:rPr>
+              <a:t>Quiz relâmpago</a:t>
+            </a:r>
+            <a:endParaRPr lang="en-US" sz="2200" dirty="0"/>
+          </a:p>
+          <a:p>
+            <a:pPr marL="342900" indent="-342900">
+              <a:spcAft>
+                <a:spcPts val="1200"/>
+              </a:spcAft>
+              <a:buSzPct val="100000"/>
+              <a:buFont typeface="+mj-lt"/>
+              <a:buAutoNum type="arabicPeriod" startAt="1"/>
+            </a:pPr>
+            <a:r>
+              <a:rPr lang="en-US" sz="2200" dirty="0">
+                <a:solidFill>
+                  <a:srgbClr val="1F2937"/>
+                </a:solidFill>
+              </a:rPr>
+              <a:t>Atividade mão na massa e síntese</a:t>
+            </a:r>
+            <a:endParaRPr lang="en-US" sz="2200" dirty="0"/>
           </a:p>
         </p:txBody>
       </p:sp>
@@ -3053,7 +5174,7 @@
                 <a:ea typeface="Calibri" pitchFamily="34" charset="-122"/>
                 <a:cs typeface="Calibri" pitchFamily="34" charset="-120"/>
               </a:rPr>
-              <a:t>Objetivos do capítulo</a:t>
+              <a:t>Situação inicial: como uma máquina aprende?</a:t>
             </a:r>
             <a:endParaRPr lang="en-US" sz="2600" dirty="0"/>
           </a:p>
@@ -3095,7 +5216,7 @@
                   <a:srgbClr val="1F2937"/>
                 </a:solidFill>
               </a:rPr>
-              <a:t>Descrever o neurônio artificial e as camadas</a:t>
+              <a:t>Ninguém programa a regra: ela é ajustada a partir de exemplos</a:t>
             </a:r>
             <a:endParaRPr lang="en-US" sz="2400" dirty="0"/>
           </a:p>
@@ -3113,7 +5234,7 @@
                   <a:srgbClr val="1F2937"/>
                 </a:solidFill>
               </a:rPr>
-              <a:t>Distinguir aprendizado supervisionado de não supervisionado</a:t>
+              <a:t>Aprender = reduzir um erro medido nos dados</a:t>
             </a:r>
             <a:endParaRPr lang="en-US" sz="2400" dirty="0"/>
           </a:p>
@@ -3131,25 +5252,7 @@
                   <a:srgbClr val="1F2937"/>
                 </a:solidFill>
               </a:rPr>
-              <a:t>Entender erro, pesos e treinamento</a:t>
-            </a:r>
-            <a:endParaRPr lang="en-US" sz="2400" dirty="0"/>
-          </a:p>
-          <a:p>
-            <a:pPr marL="342900" indent="-342900">
-              <a:spcAft>
-                <a:spcPts val="1400"/>
-              </a:spcAft>
-              <a:buSzPct val="100000"/>
-              <a:buChar char="•"/>
-            </a:pPr>
-            <a:r>
-              <a:rPr lang="en-US" sz="2400" dirty="0">
-                <a:solidFill>
-                  <a:srgbClr val="1F2937"/>
-                </a:solidFill>
-              </a:rPr>
-              <a:t>Treinar uma primeira rede em Python</a:t>
+              <a:t>Hoje: o mapa do livro e a primeira rede funcionando</a:t>
             </a:r>
             <a:endParaRPr lang="en-US" sz="2400" dirty="0"/>
           </a:p>
@@ -3260,46 +5363,22 @@
                 <a:ea typeface="Calibri" pitchFamily="34" charset="-122"/>
                 <a:cs typeface="Calibri" pitchFamily="34" charset="-120"/>
               </a:rPr>
-              <a:t>Linha do tempo</a:t>
+              <a:t>Objetivos do capítulo</a:t>
             </a:r>
             <a:endParaRPr lang="en-US" sz="2600" dirty="0"/>
           </a:p>
         </p:txBody>
       </p:sp>
-      <p:pic>
-        <p:nvPicPr>
-          <p:cNvPr id="3" name="Image 0" descr="Do neurônio de McCulloch e Pitts ao backpropagation e aos métodos de segunda ordem.">    </p:cNvPr>
-          <p:cNvPicPr>
-            <a:picLocks noChangeAspect="1"/>
-          </p:cNvPicPr>
-          <p:nvPr/>
-        </p:nvPicPr>
-        <p:blipFill>
-          <a:blip r:embed="rId1"/>
-          <a:stretch>
-            <a:fillRect/>
-          </a:stretch>
-        </p:blipFill>
-        <p:spPr>
-          <a:xfrm>
-            <a:off x="955103" y="1005840"/>
-            <a:ext cx="7233793" cy="3154680"/>
-          </a:xfrm>
-          <a:prstGeom prst="rect">
-            <a:avLst/>
-          </a:prstGeom>
-        </p:spPr>
-      </p:pic>
-      <p:sp>
-        <p:nvSpPr>
-          <p:cNvPr id="4" name="Text 1"/>
+      <p:sp>
+        <p:nvSpPr>
+          <p:cNvPr id="3" name="Text 1"/>
           <p:cNvSpPr txBox="1"/>
           <p:nvPr/>
         </p:nvSpPr>
         <p:spPr>
           <a:xfrm>
-            <a:off x="457200" y="4251960"/>
-            <a:ext cx="8229600" cy="457200"/>
+            <a:off x="548640" y="1188720"/>
+            <a:ext cx="8046720" cy="3383280"/>
           </a:xfrm>
           <a:prstGeom prst="rect">
             <a:avLst/>
@@ -3313,18 +5392,76 @@
           </a:bodyPr>
           <a:lstStyle/>
           <a:p>
-            <a:pPr algn="ctr" indent="0" marL="0">
-              <a:buNone/>
-            </a:pPr>
-            <a:r>
-              <a:rPr lang="en-US" sz="1400" i="1" dirty="0">
-                <a:solidFill>
-                  <a:srgbClr val="4B5563"/>
-                </a:solidFill>
-              </a:rPr>
-              <a:t>Do neurônio de McCulloch e Pitts ao backpropagation e aos métodos de segunda ordem.</a:t>
-            </a:r>
-            <a:endParaRPr lang="en-US" sz="1400" dirty="0"/>
+            <a:pPr marL="342900" indent="-342900">
+              <a:spcAft>
+                <a:spcPts val="1400"/>
+              </a:spcAft>
+              <a:buSzPct val="100000"/>
+              <a:buChar char="•"/>
+            </a:pPr>
+            <a:r>
+              <a:rPr lang="en-US" sz="2400" dirty="0">
+                <a:solidFill>
+                  <a:srgbClr val="1F2937"/>
+                </a:solidFill>
+              </a:rPr>
+              <a:t>Descrever o neurônio artificial e as camadas</a:t>
+            </a:r>
+            <a:endParaRPr lang="en-US" sz="2400" dirty="0"/>
+          </a:p>
+          <a:p>
+            <a:pPr marL="342900" indent="-342900">
+              <a:spcAft>
+                <a:spcPts val="1400"/>
+              </a:spcAft>
+              <a:buSzPct val="100000"/>
+              <a:buChar char="•"/>
+            </a:pPr>
+            <a:r>
+              <a:rPr lang="en-US" sz="2400" dirty="0">
+                <a:solidFill>
+                  <a:srgbClr val="1F2937"/>
+                </a:solidFill>
+              </a:rPr>
+              <a:t>Distinguir aprendizado supervisionado de não supervisionado</a:t>
+            </a:r>
+            <a:endParaRPr lang="en-US" sz="2400" dirty="0"/>
+          </a:p>
+          <a:p>
+            <a:pPr marL="342900" indent="-342900">
+              <a:spcAft>
+                <a:spcPts val="1400"/>
+              </a:spcAft>
+              <a:buSzPct val="100000"/>
+              <a:buChar char="•"/>
+            </a:pPr>
+            <a:r>
+              <a:rPr lang="en-US" sz="2400" dirty="0">
+                <a:solidFill>
+                  <a:srgbClr val="1F2937"/>
+                </a:solidFill>
+              </a:rPr>
+              <a:t>Entender erro, pesos e treinamento</a:t>
+            </a:r>
+            <a:endParaRPr lang="en-US" sz="2400" dirty="0"/>
+          </a:p>
+          <a:p>
+            <a:pPr marL="342900" indent="-342900">
+              <a:spcAft>
+                <a:spcPts val="1400"/>
+              </a:spcAft>
+              <a:buSzPct val="100000"/>
+              <a:buChar char="•"/>
+            </a:pPr>
+            <a:r>
+              <a:rPr lang="en-US" sz="2400" dirty="0">
+                <a:solidFill>
+                  <a:srgbClr val="1F2937"/>
+                </a:solidFill>
+              </a:rPr>
+              <a:t>Treinar uma primeira rede em Python</a:t>
+            </a:r>
+            <a:endParaRPr lang="en-US" sz="2400" dirty="0"/>
           </a:p>
         </p:txBody>
       </p:sp>
@@ -3433,46 +5570,85 @@
                 <a:ea typeface="Calibri" pitchFamily="34" charset="-122"/>
                 <a:cs typeface="Calibri" pitchFamily="34" charset="-120"/>
               </a:rPr>
-              <a:t>O neurônio artificial</a:t>
+              <a:t>Analogia: a mesa de som</a:t>
             </a:r>
             <a:endParaRPr lang="en-US" sz="2600" dirty="0"/>
           </a:p>
         </p:txBody>
       </p:sp>
-      <p:pic>
-        <p:nvPicPr>
-          <p:cNvPr id="3" name="Image 0" descr="Soma ponderada das entradas, mais o viés, seguida de uma ativação.">    </p:cNvPr>
-          <p:cNvPicPr>
-            <a:picLocks noChangeAspect="1"/>
-          </p:cNvPicPr>
-          <p:nvPr/>
-        </p:nvPicPr>
-        <p:blipFill>
-          <a:blip r:embed="rId1"/>
-          <a:stretch>
-            <a:fillRect/>
-          </a:stretch>
-        </p:blipFill>
-        <p:spPr>
-          <a:xfrm>
-            <a:off x="457200" y="1005840"/>
-            <a:ext cx="8229600" cy="2596669"/>
-          </a:xfrm>
-          <a:prstGeom prst="rect">
-            <a:avLst/>
-          </a:prstGeom>
-        </p:spPr>
-      </p:pic>
-      <p:sp>
-        <p:nvSpPr>
-          <p:cNvPr id="4" name="Text 1"/>
+      <p:sp>
+        <p:nvSpPr>
+          <p:cNvPr id="3" name="Shape 1"/>
+          <p:cNvSpPr/>
+          <p:nvPr/>
+        </p:nvSpPr>
+        <p:spPr>
+          <a:xfrm>
+            <a:off x="548640" y="1188720"/>
+            <a:ext cx="8046720" cy="3108960"/>
+          </a:xfrm>
+          <a:prstGeom prst="roundRect">
+            <a:avLst>
+              <a:gd name="adj" fmla="val 3529"/>
+            </a:avLst>
+          </a:prstGeom>
+          <a:solidFill>
+            <a:srgbClr val="ECFEFF"/>
+          </a:solidFill>
+          <a:ln w="25400">
+            <a:solidFill>
+              <a:srgbClr val="06B6D4"/>
+            </a:solidFill>
+            <a:prstDash val="solid"/>
+          </a:ln>
+        </p:spPr>
+      </p:sp>
+      <p:sp>
+        <p:nvSpPr>
+          <p:cNvPr id="4" name="Text 2"/>
           <p:cNvSpPr txBox="1"/>
           <p:nvPr/>
         </p:nvSpPr>
         <p:spPr>
           <a:xfrm>
-            <a:off x="457200" y="3693949"/>
-            <a:ext cx="8229600" cy="457200"/>
+            <a:off x="822960" y="1325880"/>
+            <a:ext cx="3657600" cy="365760"/>
+          </a:xfrm>
+          <a:prstGeom prst="rect">
+            <a:avLst/>
+          </a:prstGeom>
+          <a:noFill/>
+          <a:ln/>
+        </p:spPr>
+        <p:txBody>
+          <a:bodyPr wrap="square" lIns="0" tIns="0" rIns="0" bIns="0" rtlCol="0" anchor="ctr"/>
+          <a:lstStyle/>
+          <a:p>
+            <a:pPr indent="0" marL="0">
+              <a:buNone/>
+            </a:pPr>
+            <a:r>
+              <a:rPr lang="en-US" sz="1400" b="1" spc="300" kern="0" dirty="0">
+                <a:solidFill>
+                  <a:srgbClr val="0E7490"/>
+                </a:solidFill>
+              </a:rPr>
+              <a:t>NO SEU DIA A DIA</a:t>
+            </a:r>
+            <a:endParaRPr lang="en-US" sz="1400" dirty="0"/>
+          </a:p>
+        </p:txBody>
+      </p:sp>
+      <p:sp>
+        <p:nvSpPr>
+          <p:cNvPr id="5" name="Text 3"/>
+          <p:cNvSpPr txBox="1"/>
+          <p:nvPr/>
+        </p:nvSpPr>
+        <p:spPr>
+          <a:xfrm>
+            <a:off x="822960" y="1783080"/>
+            <a:ext cx="7498080" cy="2377440"/>
           </a:xfrm>
           <a:prstGeom prst="rect">
             <a:avLst/>
@@ -3486,18 +5662,18 @@
           </a:bodyPr>
           <a:lstStyle/>
           <a:p>
-            <a:pPr algn="ctr" indent="0" marL="0">
+            <a:pPr indent="0" marL="0">
               <a:buNone/>
             </a:pPr>
             <a:r>
-              <a:rPr lang="en-US" sz="1400" i="1" dirty="0">
-                <a:solidFill>
-                  <a:srgbClr val="4B5563"/>
-                </a:solidFill>
-              </a:rPr>
-              <a:t>Soma ponderada das entradas, mais o viés, seguida de uma ativação.</a:t>
-            </a:r>
-            <a:endParaRPr lang="en-US" sz="1400" dirty="0"/>
+              <a:rPr lang="en-US" sz="2100" dirty="0">
+                <a:solidFill>
+                  <a:srgbClr val="1F2937"/>
+                </a:solidFill>
+              </a:rPr>
+              <a:t>Uma rede é uma mesa de som cheia de botões (os pesos). Treinar é girar cada botão, um pouco de cada vez, até a mistura (a saída) ficar parecida com a música desejada (o alvo). O gradiente é o aviso que diz, para cada botão, em que direção e quanto girar.</a:t>
+            </a:r>
+            <a:endParaRPr lang="en-US" sz="2100" dirty="0"/>
           </a:p>
         </p:txBody>
       </p:sp>
@@ -3606,49 +5782,46 @@
                 <a:ea typeface="Calibri" pitchFamily="34" charset="-122"/>
                 <a:cs typeface="Calibri" pitchFamily="34" charset="-120"/>
               </a:rPr>
-              <a:t>O que o neurônio calcula</a:t>
+              <a:t>Linha do tempo</a:t>
             </a:r>
             <a:endParaRPr lang="en-US" sz="2600" dirty="0"/>
           </a:p>
         </p:txBody>
       </p:sp>
-      <p:sp>
-        <p:nvSpPr>
-          <p:cNvPr id="3" name="Shape 1"/>
-          <p:cNvSpPr/>
-          <p:nvPr/>
-        </p:nvSpPr>
-        <p:spPr>
-          <a:xfrm>
-            <a:off x="457200" y="1097280"/>
-            <a:ext cx="8229600" cy="868680"/>
-          </a:xfrm>
-          <a:prstGeom prst="roundRect">
-            <a:avLst>
-              <a:gd name="adj" fmla="val 8421"/>
-            </a:avLst>
-          </a:prstGeom>
-          <a:solidFill>
-            <a:srgbClr val="E0E7FF"/>
-          </a:solidFill>
-          <a:ln w="9525">
-            <a:solidFill>
-              <a:srgbClr val="C7D2FE"/>
-            </a:solidFill>
-            <a:prstDash val="solid"/>
-          </a:ln>
-        </p:spPr>
-      </p:sp>
-      <p:sp>
-        <p:nvSpPr>
-          <p:cNvPr id="4" name="Text 2"/>
+      <p:pic>
+        <p:nvPicPr>
+          <p:cNvPr id="3" name="Image 0" descr="Do neurônio de McCulloch e Pitts ao backpropagation e aos métodos de segunda ordem.">    </p:cNvPr>
+          <p:cNvPicPr>
+            <a:picLocks noChangeAspect="1"/>
+          </p:cNvPicPr>
+          <p:nvPr/>
+        </p:nvPicPr>
+        <p:blipFill>
+          <a:blip r:embed="rId1"/>
+          <a:stretch>
+            <a:fillRect/>
+          </a:stretch>
+        </p:blipFill>
+        <p:spPr>
+          <a:xfrm>
+            <a:off x="955103" y="1005840"/>
+            <a:ext cx="7233793" cy="3154680"/>
+          </a:xfrm>
+          <a:prstGeom prst="rect">
+            <a:avLst/>
+          </a:prstGeom>
+        </p:spPr>
+      </p:pic>
+      <p:sp>
+        <p:nvSpPr>
+          <p:cNvPr id="4" name="Text 1"/>
           <p:cNvSpPr txBox="1"/>
           <p:nvPr/>
         </p:nvSpPr>
         <p:spPr>
           <a:xfrm>
-            <a:off x="594360" y="1097280"/>
-            <a:ext cx="2743200" cy="868680"/>
+            <a:off x="457200" y="4251960"/>
+            <a:ext cx="8229600" cy="457200"/>
           </a:xfrm>
           <a:prstGeom prst="rect">
             <a:avLst/>
@@ -3657,276 +5830,23 @@
           <a:ln/>
         </p:spPr>
         <p:txBody>
-          <a:bodyPr wrap="square" lIns="0" tIns="0" rIns="0" bIns="0" rtlCol="0" anchor="ctr">
+          <a:bodyPr wrap="square" lIns="0" tIns="0" rIns="0" bIns="0" rtlCol="0" anchor="t">
             <a:normAutofit/>
           </a:bodyPr>
           <a:lstStyle/>
           <a:p>
-            <a:pPr indent="0" marL="0">
+            <a:pPr algn="ctr" indent="0" marL="0">
               <a:buNone/>
             </a:pPr>
             <a:r>
-              <a:rPr lang="en-US" sz="1400" b="1" dirty="0">
-                <a:solidFill>
-                  <a:srgbClr val="312E81"/>
-                </a:solidFill>
-              </a:rPr>
-              <a:t>1. Soma ponderada</a:t>
+              <a:rPr lang="en-US" sz="1400" i="1" dirty="0">
+                <a:solidFill>
+                  <a:srgbClr val="4B5563"/>
+                </a:solidFill>
+              </a:rPr>
+              <a:t>Do neurônio de McCulloch e Pitts ao backpropagation e aos métodos de segunda ordem.</a:t>
             </a:r>
             <a:endParaRPr lang="en-US" sz="1400" dirty="0"/>
-          </a:p>
-        </p:txBody>
-      </p:sp>
-      <p:sp>
-        <p:nvSpPr>
-          <p:cNvPr id="5" name="Text 3"/>
-          <p:cNvSpPr txBox="1"/>
-          <p:nvPr/>
-        </p:nvSpPr>
-        <p:spPr>
-          <a:xfrm>
-            <a:off x="3383280" y="1097280"/>
-            <a:ext cx="5212080" cy="868680"/>
-          </a:xfrm>
-          <a:prstGeom prst="rect">
-            <a:avLst/>
-          </a:prstGeom>
-          <a:noFill/>
-          <a:ln/>
-        </p:spPr>
-        <p:txBody>
-          <a:bodyPr wrap="square" lIns="0" tIns="0" rIns="0" bIns="0" rtlCol="0" anchor="ctr">
-            <a:normAutofit/>
-          </a:bodyPr>
-          <a:lstStyle/>
-          <a:p>
-            <a:pPr indent="0" marL="0">
-              <a:buNone/>
-            </a:pPr>
-            <a:r>
-              <a:rPr lang="en-US" sz="1700" dirty="0">
-                <a:solidFill>
-                  <a:srgbClr val="1F2937"/>
-                </a:solidFill>
-                <a:latin typeface="Cambria Math" pitchFamily="34" charset="0"/>
-                <a:ea typeface="Cambria Math" pitchFamily="34" charset="-122"/>
-                <a:cs typeface="Cambria Math" pitchFamily="34" charset="-120"/>
-              </a:rPr>
-              <a:t>z = w₁x₁ + w₂x₂ + … + wₙxₙ + b</a:t>
-            </a:r>
-            <a:endParaRPr lang="en-US" sz="1700" dirty="0"/>
-          </a:p>
-        </p:txBody>
-      </p:sp>
-      <p:sp>
-        <p:nvSpPr>
-          <p:cNvPr id="6" name="Shape 4"/>
-          <p:cNvSpPr/>
-          <p:nvPr/>
-        </p:nvSpPr>
-        <p:spPr>
-          <a:xfrm>
-            <a:off x="457200" y="2039112"/>
-            <a:ext cx="8229600" cy="868680"/>
-          </a:xfrm>
-          <a:prstGeom prst="roundRect">
-            <a:avLst>
-              <a:gd name="adj" fmla="val 8421"/>
-            </a:avLst>
-          </a:prstGeom>
-          <a:solidFill>
-            <a:srgbClr val="EEF2FF"/>
-          </a:solidFill>
-          <a:ln w="9525">
-            <a:solidFill>
-              <a:srgbClr val="C7D2FE"/>
-            </a:solidFill>
-            <a:prstDash val="solid"/>
-          </a:ln>
-        </p:spPr>
-      </p:sp>
-      <p:sp>
-        <p:nvSpPr>
-          <p:cNvPr id="7" name="Text 5"/>
-          <p:cNvSpPr txBox="1"/>
-          <p:nvPr/>
-        </p:nvSpPr>
-        <p:spPr>
-          <a:xfrm>
-            <a:off x="594360" y="2039112"/>
-            <a:ext cx="2743200" cy="868680"/>
-          </a:xfrm>
-          <a:prstGeom prst="rect">
-            <a:avLst/>
-          </a:prstGeom>
-          <a:noFill/>
-          <a:ln/>
-        </p:spPr>
-        <p:txBody>
-          <a:bodyPr wrap="square" lIns="0" tIns="0" rIns="0" bIns="0" rtlCol="0" anchor="ctr">
-            <a:normAutofit/>
-          </a:bodyPr>
-          <a:lstStyle/>
-          <a:p>
-            <a:pPr indent="0" marL="0">
-              <a:buNone/>
-            </a:pPr>
-            <a:r>
-              <a:rPr lang="en-US" sz="1400" b="1" dirty="0">
-                <a:solidFill>
-                  <a:srgbClr val="312E81"/>
-                </a:solidFill>
-              </a:rPr>
-              <a:t>2. Ativação</a:t>
-            </a:r>
-            <a:endParaRPr lang="en-US" sz="1400" dirty="0"/>
-          </a:p>
-        </p:txBody>
-      </p:sp>
-      <p:sp>
-        <p:nvSpPr>
-          <p:cNvPr id="8" name="Text 6"/>
-          <p:cNvSpPr txBox="1"/>
-          <p:nvPr/>
-        </p:nvSpPr>
-        <p:spPr>
-          <a:xfrm>
-            <a:off x="3383280" y="2039112"/>
-            <a:ext cx="5212080" cy="868680"/>
-          </a:xfrm>
-          <a:prstGeom prst="rect">
-            <a:avLst/>
-          </a:prstGeom>
-          <a:noFill/>
-          <a:ln/>
-        </p:spPr>
-        <p:txBody>
-          <a:bodyPr wrap="square" lIns="0" tIns="0" rIns="0" bIns="0" rtlCol="0" anchor="ctr">
-            <a:normAutofit/>
-          </a:bodyPr>
-          <a:lstStyle/>
-          <a:p>
-            <a:pPr indent="0" marL="0">
-              <a:buNone/>
-            </a:pPr>
-            <a:r>
-              <a:rPr lang="en-US" sz="1700" dirty="0">
-                <a:solidFill>
-                  <a:srgbClr val="1F2937"/>
-                </a:solidFill>
-                <a:latin typeface="Cambria Math" pitchFamily="34" charset="0"/>
-                <a:ea typeface="Cambria Math" pitchFamily="34" charset="-122"/>
-                <a:cs typeface="Cambria Math" pitchFamily="34" charset="-120"/>
-              </a:rPr>
-              <a:t>a = f(z)</a:t>
-            </a:r>
-            <a:endParaRPr lang="en-US" sz="1700" dirty="0"/>
-          </a:p>
-        </p:txBody>
-      </p:sp>
-      <p:sp>
-        <p:nvSpPr>
-          <p:cNvPr id="9" name="Shape 7"/>
-          <p:cNvSpPr/>
-          <p:nvPr/>
-        </p:nvSpPr>
-        <p:spPr>
-          <a:xfrm>
-            <a:off x="457200" y="2980944"/>
-            <a:ext cx="8229600" cy="868680"/>
-          </a:xfrm>
-          <a:prstGeom prst="roundRect">
-            <a:avLst>
-              <a:gd name="adj" fmla="val 8421"/>
-            </a:avLst>
-          </a:prstGeom>
-          <a:solidFill>
-            <a:srgbClr val="E0E7FF"/>
-          </a:solidFill>
-          <a:ln w="9525">
-            <a:solidFill>
-              <a:srgbClr val="C7D2FE"/>
-            </a:solidFill>
-            <a:prstDash val="solid"/>
-          </a:ln>
-        </p:spPr>
-      </p:sp>
-      <p:sp>
-        <p:nvSpPr>
-          <p:cNvPr id="10" name="Text 8"/>
-          <p:cNvSpPr txBox="1"/>
-          <p:nvPr/>
-        </p:nvSpPr>
-        <p:spPr>
-          <a:xfrm>
-            <a:off x="594360" y="2980944"/>
-            <a:ext cx="2743200" cy="868680"/>
-          </a:xfrm>
-          <a:prstGeom prst="rect">
-            <a:avLst/>
-          </a:prstGeom>
-          <a:noFill/>
-          <a:ln/>
-        </p:spPr>
-        <p:txBody>
-          <a:bodyPr wrap="square" lIns="0" tIns="0" rIns="0" bIns="0" rtlCol="0" anchor="ctr">
-            <a:normAutofit/>
-          </a:bodyPr>
-          <a:lstStyle/>
-          <a:p>
-            <a:pPr indent="0" marL="0">
-              <a:buNone/>
-            </a:pPr>
-            <a:r>
-              <a:rPr lang="en-US" sz="1400" b="1" dirty="0">
-                <a:solidFill>
-                  <a:srgbClr val="312E81"/>
-                </a:solidFill>
-              </a:rPr>
-              <a:t>3. Em forma vetorial</a:t>
-            </a:r>
-            <a:endParaRPr lang="en-US" sz="1400" dirty="0"/>
-          </a:p>
-        </p:txBody>
-      </p:sp>
-      <p:sp>
-        <p:nvSpPr>
-          <p:cNvPr id="11" name="Text 9"/>
-          <p:cNvSpPr txBox="1"/>
-          <p:nvPr/>
-        </p:nvSpPr>
-        <p:spPr>
-          <a:xfrm>
-            <a:off x="3383280" y="2980944"/>
-            <a:ext cx="5212080" cy="868680"/>
-          </a:xfrm>
-          <a:prstGeom prst="rect">
-            <a:avLst/>
-          </a:prstGeom>
-          <a:noFill/>
-          <a:ln/>
-        </p:spPr>
-        <p:txBody>
-          <a:bodyPr wrap="square" lIns="0" tIns="0" rIns="0" bIns="0" rtlCol="0" anchor="ctr">
-            <a:normAutofit/>
-          </a:bodyPr>
-          <a:lstStyle/>
-          <a:p>
-            <a:pPr indent="0" marL="0">
-              <a:buNone/>
-            </a:pPr>
-            <a:r>
-              <a:rPr lang="en-US" sz="1700" dirty="0">
-                <a:solidFill>
-                  <a:srgbClr val="1F2937"/>
-                </a:solidFill>
-                <a:latin typeface="Cambria Math" pitchFamily="34" charset="0"/>
-                <a:ea typeface="Cambria Math" pitchFamily="34" charset="-122"/>
-                <a:cs typeface="Cambria Math" pitchFamily="34" charset="-120"/>
-              </a:rPr>
-              <a:t>a = f(wᵀx + b)</a:t>
-            </a:r>
-            <a:endParaRPr lang="en-US" sz="1700" dirty="0"/>
           </a:p>
         </p:txBody>
       </p:sp>
@@ -4035,7 +5955,7 @@
                 <a:ea typeface="Calibri" pitchFamily="34" charset="-122"/>
                 <a:cs typeface="Calibri" pitchFamily="34" charset="-120"/>
               </a:rPr>
-              <a:t>Camadas e dimensões</a:t>
+              <a:t>O neurônio artificial</a:t>
             </a:r>
             <a:endParaRPr lang="en-US" sz="2600" dirty="0"/>
           </a:p>
@@ -4043,7 +5963,7 @@
       </p:sp>
       <p:pic>
         <p:nvPicPr>
-          <p:cNvPr id="3" name="Image 0" descr="Cada camada multiplica por uma matriz W de dimensão n_l × n_(l−1).">    </p:cNvPr>
+          <p:cNvPr id="3" name="Image 0" descr="Soma ponderada das entradas, mais o viés, seguida de uma ativação.">    </p:cNvPr>
           <p:cNvPicPr>
             <a:picLocks noChangeAspect="1"/>
           </p:cNvPicPr>
@@ -4057,8 +5977,8 @@
         </p:blipFill>
         <p:spPr>
           <a:xfrm>
-            <a:off x="653296" y="1005840"/>
-            <a:ext cx="7837408" cy="3154680"/>
+            <a:off x="457200" y="1005840"/>
+            <a:ext cx="8229600" cy="2596669"/>
           </a:xfrm>
           <a:prstGeom prst="rect">
             <a:avLst/>
@@ -4073,7 +5993,7 @@
         </p:nvSpPr>
         <p:spPr>
           <a:xfrm>
-            <a:off x="457200" y="4251960"/>
+            <a:off x="457200" y="3693949"/>
             <a:ext cx="8229600" cy="457200"/>
           </a:xfrm>
           <a:prstGeom prst="rect">
@@ -4097,7 +6017,7 @@
                   <a:srgbClr val="4B5563"/>
                 </a:solidFill>
               </a:rPr>
-              <a:t>Cada camada multiplica por uma matriz W de dimensão n_l × n_(l−1).</a:t>
+              <a:t>Soma ponderada das entradas, mais o viés, seguida de uma ativação.</a:t>
             </a:r>
             <a:endParaRPr lang="en-US" sz="1400" dirty="0"/>
           </a:p>
@@ -4208,7 +6128,7 @@
                 <a:ea typeface="Calibri" pitchFamily="34" charset="-122"/>
                 <a:cs typeface="Calibri" pitchFamily="34" charset="-120"/>
               </a:rPr>
-              <a:t>Aprender é diminuir um erro</a:t>
+              <a:t>O que o neurônio calcula</a:t>
             </a:r>
             <a:endParaRPr lang="en-US" sz="2600" dirty="0"/>
           </a:p>
@@ -4216,14 +6136,41 @@
       </p:sp>
       <p:sp>
         <p:nvSpPr>
-          <p:cNvPr id="3" name="Text 1"/>
+          <p:cNvPr id="3" name="Shape 1"/>
+          <p:cNvSpPr/>
+          <p:nvPr/>
+        </p:nvSpPr>
+        <p:spPr>
+          <a:xfrm>
+            <a:off x="457200" y="1097280"/>
+            <a:ext cx="8229600" cy="868680"/>
+          </a:xfrm>
+          <a:prstGeom prst="roundRect">
+            <a:avLst>
+              <a:gd name="adj" fmla="val 8421"/>
+            </a:avLst>
+          </a:prstGeom>
+          <a:solidFill>
+            <a:srgbClr val="E0E7FF"/>
+          </a:solidFill>
+          <a:ln w="9525">
+            <a:solidFill>
+              <a:srgbClr val="C7D2FE"/>
+            </a:solidFill>
+            <a:prstDash val="solid"/>
+          </a:ln>
+        </p:spPr>
+      </p:sp>
+      <p:sp>
+        <p:nvSpPr>
+          <p:cNvPr id="4" name="Text 2"/>
           <p:cNvSpPr txBox="1"/>
           <p:nvPr/>
         </p:nvSpPr>
         <p:spPr>
           <a:xfrm>
-            <a:off x="548640" y="1188720"/>
-            <a:ext cx="8046720" cy="3383280"/>
+            <a:off x="594360" y="1097280"/>
+            <a:ext cx="2743200" cy="868680"/>
           </a:xfrm>
           <a:prstGeom prst="rect">
             <a:avLst/>
@@ -4232,81 +6179,276 @@
           <a:ln/>
         </p:spPr>
         <p:txBody>
-          <a:bodyPr wrap="square" lIns="0" tIns="0" rIns="0" bIns="0" rtlCol="0" anchor="t">
+          <a:bodyPr wrap="square" lIns="0" tIns="0" rIns="0" bIns="0" rtlCol="0" anchor="ctr">
             <a:normAutofit/>
           </a:bodyPr>
           <a:lstStyle/>
           <a:p>
-            <a:pPr marL="342900" indent="-342900">
-              <a:spcAft>
-                <a:spcPts val="1400"/>
-              </a:spcAft>
-              <a:buSzPct val="100000"/>
-              <a:buChar char="•"/>
-            </a:pPr>
-            <a:r>
-              <a:rPr lang="en-US" sz="2400" dirty="0">
+            <a:pPr indent="0" marL="0">
+              <a:buNone/>
+            </a:pPr>
+            <a:r>
+              <a:rPr lang="en-US" sz="1400" b="1" dirty="0">
+                <a:solidFill>
+                  <a:srgbClr val="312E81"/>
+                </a:solidFill>
+              </a:rPr>
+              <a:t>1. Soma ponderada</a:t>
+            </a:r>
+            <a:endParaRPr lang="en-US" sz="1400" dirty="0"/>
+          </a:p>
+        </p:txBody>
+      </p:sp>
+      <p:sp>
+        <p:nvSpPr>
+          <p:cNvPr id="5" name="Text 3"/>
+          <p:cNvSpPr txBox="1"/>
+          <p:nvPr/>
+        </p:nvSpPr>
+        <p:spPr>
+          <a:xfrm>
+            <a:off x="3383280" y="1097280"/>
+            <a:ext cx="5212080" cy="868680"/>
+          </a:xfrm>
+          <a:prstGeom prst="rect">
+            <a:avLst/>
+          </a:prstGeom>
+          <a:noFill/>
+          <a:ln/>
+        </p:spPr>
+        <p:txBody>
+          <a:bodyPr wrap="square" lIns="0" tIns="0" rIns="0" bIns="0" rtlCol="0" anchor="ctr">
+            <a:normAutofit/>
+          </a:bodyPr>
+          <a:lstStyle/>
+          <a:p>
+            <a:pPr indent="0" marL="0">
+              <a:buNone/>
+            </a:pPr>
+            <a:r>
+              <a:rPr lang="en-US" sz="1700" dirty="0">
                 <a:solidFill>
                   <a:srgbClr val="1F2937"/>
                 </a:solidFill>
-              </a:rPr>
-              <a:t>Resíduo: r = y − t (saída menos alvo)</a:t>
-            </a:r>
-            <a:endParaRPr lang="en-US" sz="2400" dirty="0"/>
-          </a:p>
-          <a:p>
-            <a:pPr marL="342900" indent="-342900">
-              <a:spcAft>
-                <a:spcPts val="1400"/>
-              </a:spcAft>
-              <a:buSzPct val="100000"/>
-              <a:buChar char="•"/>
-            </a:pPr>
-            <a:r>
-              <a:rPr lang="en-US" sz="2400" dirty="0">
+                <a:latin typeface="Cambria Math" pitchFamily="34" charset="0"/>
+                <a:ea typeface="Cambria Math" pitchFamily="34" charset="-122"/>
+                <a:cs typeface="Cambria Math" pitchFamily="34" charset="-120"/>
+              </a:rPr>
+              <a:t>z = w₁x₁ + w₂x₂ + … + wₙxₙ + b</a:t>
+            </a:r>
+            <a:endParaRPr lang="en-US" sz="1700" dirty="0"/>
+          </a:p>
+        </p:txBody>
+      </p:sp>
+      <p:sp>
+        <p:nvSpPr>
+          <p:cNvPr id="6" name="Shape 4"/>
+          <p:cNvSpPr/>
+          <p:nvPr/>
+        </p:nvSpPr>
+        <p:spPr>
+          <a:xfrm>
+            <a:off x="457200" y="2039112"/>
+            <a:ext cx="8229600" cy="868680"/>
+          </a:xfrm>
+          <a:prstGeom prst="roundRect">
+            <a:avLst>
+              <a:gd name="adj" fmla="val 8421"/>
+            </a:avLst>
+          </a:prstGeom>
+          <a:solidFill>
+            <a:srgbClr val="EEF2FF"/>
+          </a:solidFill>
+          <a:ln w="9525">
+            <a:solidFill>
+              <a:srgbClr val="C7D2FE"/>
+            </a:solidFill>
+            <a:prstDash val="solid"/>
+          </a:ln>
+        </p:spPr>
+      </p:sp>
+      <p:sp>
+        <p:nvSpPr>
+          <p:cNvPr id="7" name="Text 5"/>
+          <p:cNvSpPr txBox="1"/>
+          <p:nvPr/>
+        </p:nvSpPr>
+        <p:spPr>
+          <a:xfrm>
+            <a:off x="594360" y="2039112"/>
+            <a:ext cx="2743200" cy="868680"/>
+          </a:xfrm>
+          <a:prstGeom prst="rect">
+            <a:avLst/>
+          </a:prstGeom>
+          <a:noFill/>
+          <a:ln/>
+        </p:spPr>
+        <p:txBody>
+          <a:bodyPr wrap="square" lIns="0" tIns="0" rIns="0" bIns="0" rtlCol="0" anchor="ctr">
+            <a:normAutofit/>
+          </a:bodyPr>
+          <a:lstStyle/>
+          <a:p>
+            <a:pPr indent="0" marL="0">
+              <a:buNone/>
+            </a:pPr>
+            <a:r>
+              <a:rPr lang="en-US" sz="1400" b="1" dirty="0">
+                <a:solidFill>
+                  <a:srgbClr val="312E81"/>
+                </a:solidFill>
+              </a:rPr>
+              <a:t>2. Ativação</a:t>
+            </a:r>
+            <a:endParaRPr lang="en-US" sz="1400" dirty="0"/>
+          </a:p>
+        </p:txBody>
+      </p:sp>
+      <p:sp>
+        <p:nvSpPr>
+          <p:cNvPr id="8" name="Text 6"/>
+          <p:cNvSpPr txBox="1"/>
+          <p:nvPr/>
+        </p:nvSpPr>
+        <p:spPr>
+          <a:xfrm>
+            <a:off x="3383280" y="2039112"/>
+            <a:ext cx="5212080" cy="868680"/>
+          </a:xfrm>
+          <a:prstGeom prst="rect">
+            <a:avLst/>
+          </a:prstGeom>
+          <a:noFill/>
+          <a:ln/>
+        </p:spPr>
+        <p:txBody>
+          <a:bodyPr wrap="square" lIns="0" tIns="0" rIns="0" bIns="0" rtlCol="0" anchor="ctr">
+            <a:normAutofit/>
+          </a:bodyPr>
+          <a:lstStyle/>
+          <a:p>
+            <a:pPr indent="0" marL="0">
+              <a:buNone/>
+            </a:pPr>
+            <a:r>
+              <a:rPr lang="en-US" sz="1700" dirty="0">
                 <a:solidFill>
                   <a:srgbClr val="1F2937"/>
                 </a:solidFill>
-              </a:rPr>
-              <a:t>Erro: E = ½ Σ r²</a:t>
-            </a:r>
-            <a:endParaRPr lang="en-US" sz="2400" dirty="0"/>
-          </a:p>
-          <a:p>
-            <a:pPr marL="342900" indent="-342900">
-              <a:spcAft>
-                <a:spcPts val="1400"/>
-              </a:spcAft>
-              <a:buSzPct val="100000"/>
-              <a:buChar char="•"/>
-            </a:pPr>
-            <a:r>
-              <a:rPr lang="en-US" sz="2400" dirty="0">
+                <a:latin typeface="Cambria Math" pitchFamily="34" charset="0"/>
+                <a:ea typeface="Cambria Math" pitchFamily="34" charset="-122"/>
+                <a:cs typeface="Cambria Math" pitchFamily="34" charset="-120"/>
+              </a:rPr>
+              <a:t>a = f(z)</a:t>
+            </a:r>
+            <a:endParaRPr lang="en-US" sz="1700" dirty="0"/>
+          </a:p>
+        </p:txBody>
+      </p:sp>
+      <p:sp>
+        <p:nvSpPr>
+          <p:cNvPr id="9" name="Shape 7"/>
+          <p:cNvSpPr/>
+          <p:nvPr/>
+        </p:nvSpPr>
+        <p:spPr>
+          <a:xfrm>
+            <a:off x="457200" y="2980944"/>
+            <a:ext cx="8229600" cy="868680"/>
+          </a:xfrm>
+          <a:prstGeom prst="roundRect">
+            <a:avLst>
+              <a:gd name="adj" fmla="val 8421"/>
+            </a:avLst>
+          </a:prstGeom>
+          <a:solidFill>
+            <a:srgbClr val="E0E7FF"/>
+          </a:solidFill>
+          <a:ln w="9525">
+            <a:solidFill>
+              <a:srgbClr val="C7D2FE"/>
+            </a:solidFill>
+            <a:prstDash val="solid"/>
+          </a:ln>
+        </p:spPr>
+      </p:sp>
+      <p:sp>
+        <p:nvSpPr>
+          <p:cNvPr id="10" name="Text 8"/>
+          <p:cNvSpPr txBox="1"/>
+          <p:nvPr/>
+        </p:nvSpPr>
+        <p:spPr>
+          <a:xfrm>
+            <a:off x="594360" y="2980944"/>
+            <a:ext cx="2743200" cy="868680"/>
+          </a:xfrm>
+          <a:prstGeom prst="rect">
+            <a:avLst/>
+          </a:prstGeom>
+          <a:noFill/>
+          <a:ln/>
+        </p:spPr>
+        <p:txBody>
+          <a:bodyPr wrap="square" lIns="0" tIns="0" rIns="0" bIns="0" rtlCol="0" anchor="ctr">
+            <a:normAutofit/>
+          </a:bodyPr>
+          <a:lstStyle/>
+          <a:p>
+            <a:pPr indent="0" marL="0">
+              <a:buNone/>
+            </a:pPr>
+            <a:r>
+              <a:rPr lang="en-US" sz="1400" b="1" dirty="0">
+                <a:solidFill>
+                  <a:srgbClr val="312E81"/>
+                </a:solidFill>
+              </a:rPr>
+              <a:t>3. Em forma vetorial</a:t>
+            </a:r>
+            <a:endParaRPr lang="en-US" sz="1400" dirty="0"/>
+          </a:p>
+        </p:txBody>
+      </p:sp>
+      <p:sp>
+        <p:nvSpPr>
+          <p:cNvPr id="11" name="Text 9"/>
+          <p:cNvSpPr txBox="1"/>
+          <p:nvPr/>
+        </p:nvSpPr>
+        <p:spPr>
+          <a:xfrm>
+            <a:off x="3383280" y="2980944"/>
+            <a:ext cx="5212080" cy="868680"/>
+          </a:xfrm>
+          <a:prstGeom prst="rect">
+            <a:avLst/>
+          </a:prstGeom>
+          <a:noFill/>
+          <a:ln/>
+        </p:spPr>
+        <p:txBody>
+          <a:bodyPr wrap="square" lIns="0" tIns="0" rIns="0" bIns="0" rtlCol="0" anchor="ctr">
+            <a:normAutofit/>
+          </a:bodyPr>
+          <a:lstStyle/>
+          <a:p>
+            <a:pPr indent="0" marL="0">
+              <a:buNone/>
+            </a:pPr>
+            <a:r>
+              <a:rPr lang="en-US" sz="1700" dirty="0">
                 <a:solidFill>
                   <a:srgbClr val="1F2937"/>
                 </a:solidFill>
-              </a:rPr>
-              <a:t>Treinar = escolher θ que torna E pequeno</a:t>
-            </a:r>
-            <a:endParaRPr lang="en-US" sz="2400" dirty="0"/>
-          </a:p>
-          <a:p>
-            <a:pPr marL="342900" indent="-342900">
-              <a:spcAft>
-                <a:spcPts val="1400"/>
-              </a:spcAft>
-              <a:buSzPct val="100000"/>
-              <a:buChar char="•"/>
-            </a:pPr>
-            <a:r>
-              <a:rPr lang="en-US" sz="2400" dirty="0">
-                <a:solidFill>
-                  <a:srgbClr val="1F2937"/>
-                </a:solidFill>
-              </a:rPr>
-              <a:t>Mas o objetivo real é acertar em dados novos</a:t>
-            </a:r>
-            <a:endParaRPr lang="en-US" sz="2400" dirty="0"/>
+                <a:latin typeface="Cambria Math" pitchFamily="34" charset="0"/>
+                <a:ea typeface="Cambria Math" pitchFamily="34" charset="-122"/>
+                <a:cs typeface="Cambria Math" pitchFamily="34" charset="-120"/>
+              </a:rPr>
+              <a:t>a = f(wᵀx + b)</a:t>
+            </a:r>
+            <a:endParaRPr lang="en-US" sz="1700" dirty="0"/>
           </a:p>
         </p:txBody>
       </p:sp>
@@ -4415,7 +6557,7 @@
                 <a:ea typeface="Calibri" pitchFamily="34" charset="-122"/>
                 <a:cs typeface="Calibri" pitchFamily="34" charset="-120"/>
               </a:rPr>
-              <a:t>A primeira rede</a:t>
+              <a:t>Camadas e dimensões</a:t>
             </a:r>
             <a:endParaRPr lang="en-US" sz="2600" dirty="0"/>
           </a:p>
@@ -4423,7 +6565,7 @@
       </p:sp>
       <p:pic>
         <p:nvPicPr>
-          <p:cNvPr id="3" name="Image 0" descr="Rede treinada com a infraestrutura didática do livro.">    </p:cNvPr>
+          <p:cNvPr id="3" name="Image 0" descr="Cada camada multiplica por uma matriz W de dimensão n_l × n_(l−1).">    </p:cNvPr>
           <p:cNvPicPr>
             <a:picLocks noChangeAspect="1"/>
           </p:cNvPicPr>
@@ -4437,8 +6579,8 @@
         </p:blipFill>
         <p:spPr>
           <a:xfrm>
-            <a:off x="910776" y="1005840"/>
-            <a:ext cx="7322448" cy="3154680"/>
+            <a:off x="653296" y="1005840"/>
+            <a:ext cx="7837408" cy="3154680"/>
           </a:xfrm>
           <a:prstGeom prst="rect">
             <a:avLst/>
@@ -4477,7 +6619,7 @@
                   <a:srgbClr val="4B5563"/>
                 </a:solidFill>
               </a:rPr>
-              <a:t>Rede treinada com a infraestrutura didática do livro.</a:t>
+              <a:t>Cada camada multiplica por uma matriz W de dimensão n_l × n_(l−1).</a:t>
             </a:r>
             <a:endParaRPr lang="en-US" sz="1400" dirty="0"/>
           </a:p>

</xml_diff>